<commit_message>
content: undergrad PPTX layout pass after visual review
Rendered all 199 slides through PowerPoint (export_pngs.ps1) and fixed
the generator: text is sized from a ladder measured with the real font
files (python-pptx's normAutofit never shrinks until edited), long
headings break at a colon, the title slide gets a unit sticker with ink
text instead of mint/orange text on paper, captions sit clear of the
frame shadow, and run spacing around " — " survives.

Every slide now uses Title Only with a hidden, off-slide title for
screen readers and Ally; window frames are marked decorative; core
properties are fixed so rebuilds churn less. Tests cover hidden titles,
contrast, measured fit, bullets on points and readings, and quote markup.

Co-Authored-By: Claude Opus 5.5 <noreply@anthropic.com>
</commit_message>
<xml_diff>
--- a/undergrad/slides/moduleone.pptx
+++ b/undergrad/slides/moduleone.pptx
@@ -3821,9 +3821,41 @@
         <p:nvPr/>
       </p:nvGrpSpPr>
       <p:grpSpPr/>
+      <p:sp>
+        <p:nvSpPr>
+          <p:cNvPr id="2" name="Title 1"/>
+          <p:cNvSpPr>
+            <a:spLocks noGrp="1"/>
+          </p:cNvSpPr>
+          <p:nvPr>
+            <p:ph type="title"/>
+          </p:nvPr>
+        </p:nvSpPr>
+        <p:spPr>
+          <a:xfrm>
+            <a:off x="-12191695" y="0"/>
+            <a:ext cx="12191695" cy="914400"/>
+          </a:xfrm>
+        </p:spPr>
+        <p:txBody>
+          <a:bodyPr/>
+          <a:lstStyle/>
+          <a:p>
+            <a:r>
+              <a:t>Module One: What Is Digital Humanities?</a:t>
+            </a:r>
+          </a:p>
+        </p:txBody>
+      </p:sp>
       <p:grpSp>
         <p:nvGrpSpPr>
-          <p:cNvPr id="2" name="Group 1"/>
+          <p:cNvPr id="3" name="Window ENG3861.EXE">
+            <a:extLst>
+              <a:ext uri="{C183D7F6-B498-43B3-948B-1728B52AA6E4}">
+                <adec:decorative xmlns:adec="http://schemas.microsoft.com/office/drawing/2017/decorative" val="1"/>
+              </a:ext>
+            </a:extLst>
+          </p:cNvPr>
           <p:cNvGrpSpPr/>
           <p:nvPr/>
         </p:nvGrpSpPr>
@@ -3837,7 +3869,7 @@
         </p:grpSpPr>
         <p:sp>
           <p:nvSpPr>
-            <p:cNvPr id="3" name="Rectangle 2"/>
+            <p:cNvPr id="4" name="Rectangle 3"/>
             <p:cNvSpPr/>
             <p:nvPr/>
           </p:nvSpPr>
@@ -3881,7 +3913,7 @@
         </p:sp>
         <p:sp>
           <p:nvSpPr>
-            <p:cNvPr id="4" name="Rectangle 3"/>
+            <p:cNvPr id="5" name="Rectangle 4"/>
             <p:cNvSpPr/>
             <p:nvPr/>
           </p:nvSpPr>
@@ -3927,7 +3959,7 @@
         </p:sp>
         <p:sp>
           <p:nvSpPr>
-            <p:cNvPr id="5" name="Rectangle 4"/>
+            <p:cNvPr id="6" name="Rectangle 5"/>
             <p:cNvSpPr/>
             <p:nvPr/>
           </p:nvSpPr>
@@ -3973,7 +4005,7 @@
         </p:sp>
         <p:sp>
           <p:nvSpPr>
-            <p:cNvPr id="6" name="Rectangle 5"/>
+            <p:cNvPr id="7" name="Rectangle 6"/>
             <p:cNvSpPr/>
             <p:nvPr/>
           </p:nvSpPr>
@@ -4019,7 +4051,7 @@
         </p:sp>
         <p:sp>
           <p:nvSpPr>
-            <p:cNvPr id="7" name="Rectangle 6"/>
+            <p:cNvPr id="8" name="Rectangle 7"/>
             <p:cNvSpPr/>
             <p:nvPr/>
           </p:nvSpPr>
@@ -4065,7 +4097,7 @@
         </p:sp>
         <p:sp>
           <p:nvSpPr>
-            <p:cNvPr id="8" name="Rectangle 7"/>
+            <p:cNvPr id="9" name="Rectangle 8"/>
             <p:cNvSpPr/>
             <p:nvPr/>
           </p:nvSpPr>
@@ -4111,7 +4143,7 @@
         </p:sp>
         <p:sp>
           <p:nvSpPr>
-            <p:cNvPr id="9" name="TextBox 8"/>
+            <p:cNvPr id="10" name="TextBox 9"/>
             <p:cNvSpPr txBox="1"/>
             <p:nvPr/>
           </p:nvSpPr>
@@ -4144,16 +4176,134 @@
           </p:txBody>
         </p:sp>
       </p:grpSp>
-      <p:sp>
-        <p:nvSpPr>
-          <p:cNvPr id="10" name="TextBox 9"/>
+      <p:grpSp>
+        <p:nvGrpSpPr>
+          <p:cNvPr id="11" name="Unit WORDS"/>
+          <p:cNvGrpSpPr/>
+          <p:nvPr/>
+        </p:nvGrpSpPr>
+        <p:grpSpPr>
+          <a:xfrm>
+            <a:off x="1371600" y="2596642"/>
+            <a:ext cx="1542978" cy="512064"/>
+            <a:chOff x="1371600" y="2596642"/>
+            <a:chExt cx="1542978" cy="512064"/>
+          </a:xfrm>
+        </p:grpSpPr>
+        <p:sp>
+          <p:nvSpPr>
+            <p:cNvPr id="12" name="Rounded Rectangle 11"/>
+            <p:cNvSpPr/>
+            <p:nvPr/>
+          </p:nvSpPr>
+          <p:spPr>
+            <a:xfrm>
+              <a:off x="1426464" y="2651506"/>
+              <a:ext cx="1488114" cy="457200"/>
+            </a:xfrm>
+            <a:prstGeom prst="roundRect">
+              <a:avLst>
+                <a:gd name="adj" fmla="val 50000"/>
+              </a:avLst>
+            </a:prstGeom>
+            <a:solidFill>
+              <a:srgbClr val="1B1035"/>
+            </a:solidFill>
+            <a:ln>
+              <a:noFill/>
+            </a:ln>
+            <a:effectLst/>
+          </p:spPr>
+          <p:style>
+            <a:lnRef idx="1">
+              <a:schemeClr val="accent1"/>
+            </a:lnRef>
+            <a:fillRef idx="3">
+              <a:schemeClr val="accent1"/>
+            </a:fillRef>
+            <a:effectRef idx="2">
+              <a:schemeClr val="accent1"/>
+            </a:effectRef>
+            <a:fontRef idx="minor">
+              <a:schemeClr val="lt1"/>
+            </a:fontRef>
+          </p:style>
+          <p:txBody>
+            <a:bodyPr rtlCol="0" anchor="ctr"/>
+            <a:lstStyle/>
+            <a:p>
+              <a:pPr algn="ctr"/>
+            </a:p>
+          </p:txBody>
+        </p:sp>
+        <p:sp>
+          <p:nvSpPr>
+            <p:cNvPr id="13" name="Rounded Rectangle 12"/>
+            <p:cNvSpPr/>
+            <p:nvPr/>
+          </p:nvSpPr>
+          <p:spPr>
+            <a:xfrm>
+              <a:off x="1371600" y="2596642"/>
+              <a:ext cx="1488114" cy="457200"/>
+            </a:xfrm>
+            <a:prstGeom prst="roundRect">
+              <a:avLst>
+                <a:gd name="adj" fmla="val 50000"/>
+              </a:avLst>
+            </a:prstGeom>
+            <a:solidFill>
+              <a:srgbClr val="2E5BFF"/>
+            </a:solidFill>
+            <a:ln w="31750">
+              <a:solidFill>
+                <a:srgbClr val="1B1035"/>
+              </a:solidFill>
+            </a:ln>
+            <a:effectLst/>
+          </p:spPr>
+          <p:style>
+            <a:lnRef idx="1">
+              <a:schemeClr val="accent1"/>
+            </a:lnRef>
+            <a:fillRef idx="3">
+              <a:schemeClr val="accent1"/>
+            </a:fillRef>
+            <a:effectRef idx="2">
+              <a:schemeClr val="accent1"/>
+            </a:effectRef>
+            <a:fontRef idx="minor">
+              <a:schemeClr val="lt1"/>
+            </a:fontRef>
+          </p:style>
+          <p:txBody>
+            <a:bodyPr rtlCol="0" anchor="ctr" lIns="0" rIns="0" tIns="0" bIns="0" wrap="none"/>
+            <a:lstStyle/>
+            <a:p>
+              <a:pPr algn="ctr"/>
+              <a:r>
+                <a:rPr sz="1800" b="0" i="0">
+                  <a:solidFill>
+                    <a:srgbClr val="FFFFFF"/>
+                  </a:solidFill>
+                  <a:latin typeface="Arial Black"/>
+                </a:rPr>
+                <a:t>WORDS</a:t>
+              </a:r>
+            </a:p>
+          </p:txBody>
+        </p:sp>
+      </p:grpSp>
+      <p:sp>
+        <p:nvSpPr>
+          <p:cNvPr id="14" name="TextBox 13"/>
           <p:cNvSpPr txBox="1"/>
           <p:nvPr/>
         </p:nvSpPr>
         <p:spPr>
           <a:xfrm>
-            <a:off x="1280160" y="1645920"/>
-            <a:ext cx="9631375" cy="4069080"/>
+            <a:off x="1280160" y="3236722"/>
+            <a:ext cx="9631375" cy="2478278"/>
           </a:xfrm>
           <a:prstGeom prst="rect">
             <a:avLst/>
@@ -4161,21 +4311,10 @@
           <a:noFill/>
         </p:spPr>
         <p:txBody>
-          <a:bodyPr wrap="square" anchor="ctr">
+          <a:bodyPr wrap="square" anchor="t">
             <a:normAutofit/>
           </a:bodyPr>
           <a:lstStyle/>
-          <a:p>
-            <a:r>
-              <a:rPr sz="1800" b="0" i="0">
-                <a:solidFill>
-                  <a:srgbClr val="2E5BFF"/>
-                </a:solidFill>
-                <a:latin typeface="Arial Black"/>
-              </a:rPr>
-              <a:t>WORDS</a:t>
-            </a:r>
-          </a:p>
           <a:p>
             <a:r>
               <a:rPr sz="2400" b="0" i="0">
@@ -4189,7 +4328,7 @@
           </a:p>
           <a:p>
             <a:r>
-              <a:rPr sz="4800" b="0" i="0">
+              <a:rPr sz="4400" b="0" i="0">
                 <a:solidFill>
                   <a:srgbClr val="1B1035"/>
                 </a:solidFill>
@@ -4237,9 +4376,41 @@
         <p:nvPr/>
       </p:nvGrpSpPr>
       <p:grpSpPr/>
+      <p:sp>
+        <p:nvSpPr>
+          <p:cNvPr id="2" name="Title 1"/>
+          <p:cNvSpPr>
+            <a:spLocks noGrp="1"/>
+          </p:cNvSpPr>
+          <p:nvPr>
+            <p:ph type="title"/>
+          </p:nvPr>
+        </p:nvSpPr>
+        <p:spPr>
+          <a:xfrm>
+            <a:off x="-12191695" y="0"/>
+            <a:ext cx="12191695" cy="914400"/>
+          </a:xfrm>
+        </p:spPr>
+        <p:txBody>
+          <a:bodyPr/>
+          <a:lstStyle/>
+          <a:p>
+            <a:r>
+              <a:t>ELIZA (1966): Joseph Weizenbaum's script turns your words back into questions</a:t>
+            </a:r>
+          </a:p>
+        </p:txBody>
+      </p:sp>
       <p:grpSp>
         <p:nvGrpSpPr>
-          <p:cNvPr id="2" name="Group 1"/>
+          <p:cNvPr id="3" name="Window image.png">
+            <a:extLst>
+              <a:ext uri="{C183D7F6-B498-43B3-948B-1728B52AA6E4}">
+                <adec:decorative xmlns:adec="http://schemas.microsoft.com/office/drawing/2017/decorative" val="1"/>
+              </a:ext>
+            </a:extLst>
+          </p:cNvPr>
           <p:cNvGrpSpPr/>
           <p:nvPr/>
         </p:nvGrpSpPr>
@@ -4253,7 +4424,7 @@
         </p:grpSpPr>
         <p:sp>
           <p:nvSpPr>
-            <p:cNvPr id="3" name="Rectangle 2"/>
+            <p:cNvPr id="4" name="Rectangle 3"/>
             <p:cNvSpPr/>
             <p:nvPr/>
           </p:nvSpPr>
@@ -4297,7 +4468,7 @@
         </p:sp>
         <p:sp>
           <p:nvSpPr>
-            <p:cNvPr id="4" name="Rectangle 3"/>
+            <p:cNvPr id="5" name="Rectangle 4"/>
             <p:cNvSpPr/>
             <p:nvPr/>
           </p:nvSpPr>
@@ -4343,7 +4514,7 @@
         </p:sp>
         <p:sp>
           <p:nvSpPr>
-            <p:cNvPr id="5" name="Rectangle 4"/>
+            <p:cNvPr id="6" name="Rectangle 5"/>
             <p:cNvSpPr/>
             <p:nvPr/>
           </p:nvSpPr>
@@ -4389,7 +4560,7 @@
         </p:sp>
         <p:sp>
           <p:nvSpPr>
-            <p:cNvPr id="6" name="Rectangle 5"/>
+            <p:cNvPr id="7" name="Rectangle 6"/>
             <p:cNvSpPr/>
             <p:nvPr/>
           </p:nvSpPr>
@@ -4435,7 +4606,7 @@
         </p:sp>
         <p:sp>
           <p:nvSpPr>
-            <p:cNvPr id="7" name="Rectangle 6"/>
+            <p:cNvPr id="8" name="Rectangle 7"/>
             <p:cNvSpPr/>
             <p:nvPr/>
           </p:nvSpPr>
@@ -4481,7 +4652,7 @@
         </p:sp>
         <p:sp>
           <p:nvSpPr>
-            <p:cNvPr id="8" name="Rectangle 7"/>
+            <p:cNvPr id="9" name="Rectangle 8"/>
             <p:cNvSpPr/>
             <p:nvPr/>
           </p:nvSpPr>
@@ -4527,7 +4698,7 @@
         </p:sp>
         <p:sp>
           <p:nvSpPr>
-            <p:cNvPr id="9" name="TextBox 8"/>
+            <p:cNvPr id="10" name="TextBox 9"/>
             <p:cNvSpPr txBox="1"/>
             <p:nvPr/>
           </p:nvSpPr>
@@ -4562,7 +4733,7 @@
       </p:grpSp>
       <p:pic>
         <p:nvPicPr>
-          <p:cNvPr id="10" name="Picture 9" descr="Dark terminal screen with a block-letter ELIZA banner and a transcript that begins 'Is something troubling you?' and 'Men are all alike.'"/>
+          <p:cNvPr id="11" name="Picture 10" descr="Dark terminal screen with a block-letter ELIZA banner and a transcript that begins 'Is something troubling you?' and 'Men are all alike.'"/>
           <p:cNvPicPr>
             <a:picLocks noChangeAspect="1"/>
           </p:cNvPicPr>
@@ -4586,13 +4757,13 @@
       </p:pic>
       <p:sp>
         <p:nvSpPr>
-          <p:cNvPr id="11" name="TextBox 10"/>
+          <p:cNvPr id="12" name="TextBox 11"/>
           <p:cNvSpPr txBox="1"/>
           <p:nvPr/>
         </p:nvSpPr>
         <p:spPr>
           <a:xfrm>
-            <a:off x="822960" y="5989320"/>
+            <a:off x="822960" y="5943600"/>
             <a:ext cx="10545775" cy="731520"/>
           </a:xfrm>
           <a:prstGeom prst="rect">
@@ -4645,9 +4816,41 @@
         <p:nvPr/>
       </p:nvGrpSpPr>
       <p:grpSpPr/>
+      <p:sp>
+        <p:nvSpPr>
+          <p:cNvPr id="2" name="Title 1"/>
+          <p:cNvSpPr>
+            <a:spLocks noGrp="1"/>
+          </p:cNvSpPr>
+          <p:nvPr>
+            <p:ph type="title"/>
+          </p:nvPr>
+        </p:nvSpPr>
+        <p:spPr>
+          <a:xfrm>
+            <a:off x="-12191695" y="0"/>
+            <a:ext cx="12191695" cy="914400"/>
+          </a:xfrm>
+        </p:spPr>
+        <p:txBody>
+          <a:bodyPr/>
+          <a:lstStyle/>
+          <a:p>
+            <a:r>
+              <a:t>Quote: Joseph Weizenbaum, archival recording in “The ELIZA Effect”</a:t>
+            </a:r>
+          </a:p>
+        </p:txBody>
+      </p:sp>
       <p:grpSp>
         <p:nvGrpSpPr>
-          <p:cNvPr id="2" name="Group 1"/>
+          <p:cNvPr id="3" name="Window quote.txt">
+            <a:extLst>
+              <a:ext uri="{C183D7F6-B498-43B3-948B-1728B52AA6E4}">
+                <adec:decorative xmlns:adec="http://schemas.microsoft.com/office/drawing/2017/decorative" val="1"/>
+              </a:ext>
+            </a:extLst>
+          </p:cNvPr>
           <p:cNvGrpSpPr/>
           <p:nvPr/>
         </p:nvGrpSpPr>
@@ -4661,7 +4864,7 @@
         </p:grpSpPr>
         <p:sp>
           <p:nvSpPr>
-            <p:cNvPr id="3" name="Rectangle 2"/>
+            <p:cNvPr id="4" name="Rectangle 3"/>
             <p:cNvSpPr/>
             <p:nvPr/>
           </p:nvSpPr>
@@ -4705,7 +4908,7 @@
         </p:sp>
         <p:sp>
           <p:nvSpPr>
-            <p:cNvPr id="4" name="Rectangle 3"/>
+            <p:cNvPr id="5" name="Rectangle 4"/>
             <p:cNvSpPr/>
             <p:nvPr/>
           </p:nvSpPr>
@@ -4751,7 +4954,7 @@
         </p:sp>
         <p:sp>
           <p:nvSpPr>
-            <p:cNvPr id="5" name="Rectangle 4"/>
+            <p:cNvPr id="6" name="Rectangle 5"/>
             <p:cNvSpPr/>
             <p:nvPr/>
           </p:nvSpPr>
@@ -4797,7 +5000,7 @@
         </p:sp>
         <p:sp>
           <p:nvSpPr>
-            <p:cNvPr id="6" name="Rectangle 5"/>
+            <p:cNvPr id="7" name="Rectangle 6"/>
             <p:cNvSpPr/>
             <p:nvPr/>
           </p:nvSpPr>
@@ -4843,7 +5046,7 @@
         </p:sp>
         <p:sp>
           <p:nvSpPr>
-            <p:cNvPr id="7" name="Rectangle 6"/>
+            <p:cNvPr id="8" name="Rectangle 7"/>
             <p:cNvSpPr/>
             <p:nvPr/>
           </p:nvSpPr>
@@ -4889,7 +5092,7 @@
         </p:sp>
         <p:sp>
           <p:nvSpPr>
-            <p:cNvPr id="8" name="Rectangle 7"/>
+            <p:cNvPr id="9" name="Rectangle 8"/>
             <p:cNvSpPr/>
             <p:nvPr/>
           </p:nvSpPr>
@@ -4935,7 +5138,7 @@
         </p:sp>
         <p:sp>
           <p:nvSpPr>
-            <p:cNvPr id="9" name="TextBox 8"/>
+            <p:cNvPr id="10" name="TextBox 9"/>
             <p:cNvSpPr txBox="1"/>
             <p:nvPr/>
           </p:nvSpPr>
@@ -4970,7 +5173,7 @@
       </p:grpSp>
       <p:sp>
         <p:nvSpPr>
-          <p:cNvPr id="10" name="TextBox 9"/>
+          <p:cNvPr id="11" name="TextBox 10"/>
           <p:cNvSpPr txBox="1"/>
           <p:nvPr/>
         </p:nvSpPr>
@@ -5004,7 +5207,7 @@
       </p:sp>
       <p:sp>
         <p:nvSpPr>
-          <p:cNvPr id="11" name="TextBox 10"/>
+          <p:cNvPr id="12" name="TextBox 11"/>
           <p:cNvSpPr txBox="1"/>
           <p:nvPr/>
         </p:nvSpPr>
@@ -5073,9 +5276,41 @@
         <p:nvPr/>
       </p:nvGrpSpPr>
       <p:grpSpPr/>
+      <p:sp>
+        <p:nvSpPr>
+          <p:cNvPr id="2" name="Title 1"/>
+          <p:cNvSpPr>
+            <a:spLocks noGrp="1"/>
+          </p:cNvSpPr>
+          <p:nvPr>
+            <p:ph type="title"/>
+          </p:nvPr>
+        </p:nvSpPr>
+        <p:spPr>
+          <a:xfrm>
+            <a:off x="-12191695" y="0"/>
+            <a:ext cx="12191695" cy="914400"/>
+          </a:xfrm>
+        </p:spPr>
+        <p:txBody>
+          <a:bodyPr/>
+          <a:lstStyle/>
+          <a:p>
+            <a:r>
+              <a:t>Quote: Joseph Weizenbaum, read by Roman Mars in “The ELIZA Effect”</a:t>
+            </a:r>
+          </a:p>
+        </p:txBody>
+      </p:sp>
       <p:grpSp>
         <p:nvGrpSpPr>
-          <p:cNvPr id="2" name="Group 1"/>
+          <p:cNvPr id="3" name="Window quote.txt">
+            <a:extLst>
+              <a:ext uri="{C183D7F6-B498-43B3-948B-1728B52AA6E4}">
+                <adec:decorative xmlns:adec="http://schemas.microsoft.com/office/drawing/2017/decorative" val="1"/>
+              </a:ext>
+            </a:extLst>
+          </p:cNvPr>
           <p:cNvGrpSpPr/>
           <p:nvPr/>
         </p:nvGrpSpPr>
@@ -5089,7 +5324,7 @@
         </p:grpSpPr>
         <p:sp>
           <p:nvSpPr>
-            <p:cNvPr id="3" name="Rectangle 2"/>
+            <p:cNvPr id="4" name="Rectangle 3"/>
             <p:cNvSpPr/>
             <p:nvPr/>
           </p:nvSpPr>
@@ -5133,7 +5368,7 @@
         </p:sp>
         <p:sp>
           <p:nvSpPr>
-            <p:cNvPr id="4" name="Rectangle 3"/>
+            <p:cNvPr id="5" name="Rectangle 4"/>
             <p:cNvSpPr/>
             <p:nvPr/>
           </p:nvSpPr>
@@ -5179,7 +5414,7 @@
         </p:sp>
         <p:sp>
           <p:nvSpPr>
-            <p:cNvPr id="5" name="Rectangle 4"/>
+            <p:cNvPr id="6" name="Rectangle 5"/>
             <p:cNvSpPr/>
             <p:nvPr/>
           </p:nvSpPr>
@@ -5225,7 +5460,7 @@
         </p:sp>
         <p:sp>
           <p:nvSpPr>
-            <p:cNvPr id="6" name="Rectangle 5"/>
+            <p:cNvPr id="7" name="Rectangle 6"/>
             <p:cNvSpPr/>
             <p:nvPr/>
           </p:nvSpPr>
@@ -5271,7 +5506,7 @@
         </p:sp>
         <p:sp>
           <p:nvSpPr>
-            <p:cNvPr id="7" name="Rectangle 6"/>
+            <p:cNvPr id="8" name="Rectangle 7"/>
             <p:cNvSpPr/>
             <p:nvPr/>
           </p:nvSpPr>
@@ -5317,7 +5552,7 @@
         </p:sp>
         <p:sp>
           <p:nvSpPr>
-            <p:cNvPr id="8" name="Rectangle 7"/>
+            <p:cNvPr id="9" name="Rectangle 8"/>
             <p:cNvSpPr/>
             <p:nvPr/>
           </p:nvSpPr>
@@ -5363,7 +5598,7 @@
         </p:sp>
         <p:sp>
           <p:nvSpPr>
-            <p:cNvPr id="9" name="TextBox 8"/>
+            <p:cNvPr id="10" name="TextBox 9"/>
             <p:cNvSpPr txBox="1"/>
             <p:nvPr/>
           </p:nvSpPr>
@@ -5398,7 +5633,7 @@
       </p:grpSp>
       <p:sp>
         <p:nvSpPr>
-          <p:cNvPr id="10" name="TextBox 9"/>
+          <p:cNvPr id="11" name="TextBox 10"/>
           <p:cNvSpPr txBox="1"/>
           <p:nvPr/>
         </p:nvSpPr>
@@ -5432,7 +5667,7 @@
       </p:sp>
       <p:sp>
         <p:nvSpPr>
-          <p:cNvPr id="11" name="TextBox 10"/>
+          <p:cNvPr id="12" name="TextBox 11"/>
           <p:cNvSpPr txBox="1"/>
           <p:nvPr/>
         </p:nvSpPr>
@@ -5501,9 +5736,41 @@
         <p:nvPr/>
       </p:nvGrpSpPr>
       <p:grpSpPr/>
+      <p:sp>
+        <p:nvSpPr>
+          <p:cNvPr id="2" name="Title 1"/>
+          <p:cNvSpPr>
+            <a:spLocks noGrp="1"/>
+          </p:cNvSpPr>
+          <p:nvPr>
+            <p:ph type="title"/>
+          </p:nvPr>
+        </p:nvSpPr>
+        <p:spPr>
+          <a:xfrm>
+            <a:off x="-12191695" y="0"/>
+            <a:ext cx="12191695" cy="914400"/>
+          </a:xfrm>
+        </p:spPr>
+        <p:txBody>
+          <a:bodyPr/>
+          <a:lstStyle/>
+          <a:p>
+            <a:r>
+              <a:t>Quote: Delaney Hall, “The ELIZA Effect”</a:t>
+            </a:r>
+          </a:p>
+        </p:txBody>
+      </p:sp>
       <p:grpSp>
         <p:nvGrpSpPr>
-          <p:cNvPr id="2" name="Group 1"/>
+          <p:cNvPr id="3" name="Window quote.txt">
+            <a:extLst>
+              <a:ext uri="{C183D7F6-B498-43B3-948B-1728B52AA6E4}">
+                <adec:decorative xmlns:adec="http://schemas.microsoft.com/office/drawing/2017/decorative" val="1"/>
+              </a:ext>
+            </a:extLst>
+          </p:cNvPr>
           <p:cNvGrpSpPr/>
           <p:nvPr/>
         </p:nvGrpSpPr>
@@ -5517,7 +5784,7 @@
         </p:grpSpPr>
         <p:sp>
           <p:nvSpPr>
-            <p:cNvPr id="3" name="Rectangle 2"/>
+            <p:cNvPr id="4" name="Rectangle 3"/>
             <p:cNvSpPr/>
             <p:nvPr/>
           </p:nvSpPr>
@@ -5561,7 +5828,7 @@
         </p:sp>
         <p:sp>
           <p:nvSpPr>
-            <p:cNvPr id="4" name="Rectangle 3"/>
+            <p:cNvPr id="5" name="Rectangle 4"/>
             <p:cNvSpPr/>
             <p:nvPr/>
           </p:nvSpPr>
@@ -5607,7 +5874,7 @@
         </p:sp>
         <p:sp>
           <p:nvSpPr>
-            <p:cNvPr id="5" name="Rectangle 4"/>
+            <p:cNvPr id="6" name="Rectangle 5"/>
             <p:cNvSpPr/>
             <p:nvPr/>
           </p:nvSpPr>
@@ -5653,7 +5920,7 @@
         </p:sp>
         <p:sp>
           <p:nvSpPr>
-            <p:cNvPr id="6" name="Rectangle 5"/>
+            <p:cNvPr id="7" name="Rectangle 6"/>
             <p:cNvSpPr/>
             <p:nvPr/>
           </p:nvSpPr>
@@ -5699,7 +5966,7 @@
         </p:sp>
         <p:sp>
           <p:nvSpPr>
-            <p:cNvPr id="7" name="Rectangle 6"/>
+            <p:cNvPr id="8" name="Rectangle 7"/>
             <p:cNvSpPr/>
             <p:nvPr/>
           </p:nvSpPr>
@@ -5745,7 +6012,7 @@
         </p:sp>
         <p:sp>
           <p:nvSpPr>
-            <p:cNvPr id="8" name="Rectangle 7"/>
+            <p:cNvPr id="9" name="Rectangle 8"/>
             <p:cNvSpPr/>
             <p:nvPr/>
           </p:nvSpPr>
@@ -5791,7 +6058,7 @@
         </p:sp>
         <p:sp>
           <p:nvSpPr>
-            <p:cNvPr id="9" name="TextBox 8"/>
+            <p:cNvPr id="10" name="TextBox 9"/>
             <p:cNvSpPr txBox="1"/>
             <p:nvPr/>
           </p:nvSpPr>
@@ -5826,7 +6093,7 @@
       </p:grpSp>
       <p:sp>
         <p:nvSpPr>
-          <p:cNvPr id="10" name="TextBox 9"/>
+          <p:cNvPr id="11" name="TextBox 10"/>
           <p:cNvSpPr txBox="1"/>
           <p:nvPr/>
         </p:nvSpPr>
@@ -5860,7 +6127,7 @@
       </p:sp>
       <p:sp>
         <p:nvSpPr>
-          <p:cNvPr id="11" name="TextBox 10"/>
+          <p:cNvPr id="12" name="TextBox 11"/>
           <p:cNvSpPr txBox="1"/>
           <p:nvPr/>
         </p:nvSpPr>
@@ -5929,9 +6196,41 @@
         <p:nvPr/>
       </p:nvGrpSpPr>
       <p:grpSpPr/>
+      <p:sp>
+        <p:nvSpPr>
+          <p:cNvPr id="2" name="Title 1"/>
+          <p:cNvSpPr>
+            <a:spLocks noGrp="1"/>
+          </p:cNvSpPr>
+          <p:nvPr>
+            <p:ph type="title"/>
+          </p:nvPr>
+        </p:nvSpPr>
+        <p:spPr>
+          <a:xfrm>
+            <a:off x="-12191695" y="0"/>
+            <a:ext cx="12191695" cy="914400"/>
+          </a:xfrm>
+        </p:spPr>
+        <p:txBody>
+          <a:bodyPr/>
+          <a:lstStyle/>
+          <a:p>
+            <a:r>
+              <a:t>The ELIZA effect: reading a mind into a machine that only matches patterns</a:t>
+            </a:r>
+          </a:p>
+        </p:txBody>
+      </p:sp>
       <p:grpSp>
         <p:nvGrpSpPr>
-          <p:cNvPr id="2" name="Group 1"/>
+          <p:cNvPr id="3" name="Window image.png">
+            <a:extLst>
+              <a:ext uri="{C183D7F6-B498-43B3-948B-1728B52AA6E4}">
+                <adec:decorative xmlns:adec="http://schemas.microsoft.com/office/drawing/2017/decorative" val="1"/>
+              </a:ext>
+            </a:extLst>
+          </p:cNvPr>
           <p:cNvGrpSpPr/>
           <p:nvPr/>
         </p:nvGrpSpPr>
@@ -5945,7 +6244,7 @@
         </p:grpSpPr>
         <p:sp>
           <p:nvSpPr>
-            <p:cNvPr id="3" name="Rectangle 2"/>
+            <p:cNvPr id="4" name="Rectangle 3"/>
             <p:cNvSpPr/>
             <p:nvPr/>
           </p:nvSpPr>
@@ -5989,7 +6288,7 @@
         </p:sp>
         <p:sp>
           <p:nvSpPr>
-            <p:cNvPr id="4" name="Rectangle 3"/>
+            <p:cNvPr id="5" name="Rectangle 4"/>
             <p:cNvSpPr/>
             <p:nvPr/>
           </p:nvSpPr>
@@ -6035,7 +6334,7 @@
         </p:sp>
         <p:sp>
           <p:nvSpPr>
-            <p:cNvPr id="5" name="Rectangle 4"/>
+            <p:cNvPr id="6" name="Rectangle 5"/>
             <p:cNvSpPr/>
             <p:nvPr/>
           </p:nvSpPr>
@@ -6081,7 +6380,7 @@
         </p:sp>
         <p:sp>
           <p:nvSpPr>
-            <p:cNvPr id="6" name="Rectangle 5"/>
+            <p:cNvPr id="7" name="Rectangle 6"/>
             <p:cNvSpPr/>
             <p:nvPr/>
           </p:nvSpPr>
@@ -6127,7 +6426,7 @@
         </p:sp>
         <p:sp>
           <p:nvSpPr>
-            <p:cNvPr id="7" name="Rectangle 6"/>
+            <p:cNvPr id="8" name="Rectangle 7"/>
             <p:cNvSpPr/>
             <p:nvPr/>
           </p:nvSpPr>
@@ -6173,7 +6472,7 @@
         </p:sp>
         <p:sp>
           <p:nvSpPr>
-            <p:cNvPr id="8" name="Rectangle 7"/>
+            <p:cNvPr id="9" name="Rectangle 8"/>
             <p:cNvSpPr/>
             <p:nvPr/>
           </p:nvSpPr>
@@ -6219,7 +6518,7 @@
         </p:sp>
         <p:sp>
           <p:nvSpPr>
-            <p:cNvPr id="9" name="TextBox 8"/>
+            <p:cNvPr id="10" name="TextBox 9"/>
             <p:cNvSpPr txBox="1"/>
             <p:nvPr/>
           </p:nvSpPr>
@@ -6254,7 +6553,7 @@
       </p:grpSp>
       <p:pic>
         <p:nvPicPr>
-          <p:cNvPr id="10" name="Picture 9" descr="Built In article header 'What Is the Eliza Effect?' over an illustration of a woman's face merging into a faceted digital face."/>
+          <p:cNvPr id="11" name="Picture 10" descr="Built In article header 'What Is the Eliza Effect?' over an illustration of a woman's face merging into a faceted digital face."/>
           <p:cNvPicPr>
             <a:picLocks noChangeAspect="1"/>
           </p:cNvPicPr>
@@ -6278,13 +6577,13 @@
       </p:pic>
       <p:sp>
         <p:nvSpPr>
-          <p:cNvPr id="11" name="TextBox 10"/>
+          <p:cNvPr id="12" name="TextBox 11"/>
           <p:cNvSpPr txBox="1"/>
           <p:nvPr/>
         </p:nvSpPr>
         <p:spPr>
           <a:xfrm>
-            <a:off x="822960" y="5989320"/>
+            <a:off x="822960" y="5943600"/>
             <a:ext cx="10545775" cy="731520"/>
           </a:xfrm>
           <a:prstGeom prst="rect">
@@ -6337,9 +6636,41 @@
         <p:nvPr/>
       </p:nvGrpSpPr>
       <p:grpSpPr/>
+      <p:sp>
+        <p:nvSpPr>
+          <p:cNvPr id="2" name="Title 1"/>
+          <p:cNvSpPr>
+            <a:spLocks noGrp="1"/>
+          </p:cNvSpPr>
+          <p:nvPr>
+            <p:ph type="title"/>
+          </p:nvPr>
+        </p:nvSpPr>
+        <p:spPr>
+          <a:xfrm>
+            <a:off x="-12191695" y="0"/>
+            <a:ext cx="12191695" cy="914400"/>
+          </a:xfrm>
+        </p:spPr>
+        <p:txBody>
+          <a:bodyPr/>
+          <a:lstStyle/>
+          <a:p>
+            <a:r>
+              <a:t>Quote: Miriam Weizenbaum, “The ELIZA Effect”</a:t>
+            </a:r>
+          </a:p>
+        </p:txBody>
+      </p:sp>
       <p:grpSp>
         <p:nvGrpSpPr>
-          <p:cNvPr id="2" name="Group 1"/>
+          <p:cNvPr id="3" name="Window quote.txt">
+            <a:extLst>
+              <a:ext uri="{C183D7F6-B498-43B3-948B-1728B52AA6E4}">
+                <adec:decorative xmlns:adec="http://schemas.microsoft.com/office/drawing/2017/decorative" val="1"/>
+              </a:ext>
+            </a:extLst>
+          </p:cNvPr>
           <p:cNvGrpSpPr/>
           <p:nvPr/>
         </p:nvGrpSpPr>
@@ -6353,7 +6684,7 @@
         </p:grpSpPr>
         <p:sp>
           <p:nvSpPr>
-            <p:cNvPr id="3" name="Rectangle 2"/>
+            <p:cNvPr id="4" name="Rectangle 3"/>
             <p:cNvSpPr/>
             <p:nvPr/>
           </p:nvSpPr>
@@ -6397,7 +6728,7 @@
         </p:sp>
         <p:sp>
           <p:nvSpPr>
-            <p:cNvPr id="4" name="Rectangle 3"/>
+            <p:cNvPr id="5" name="Rectangle 4"/>
             <p:cNvSpPr/>
             <p:nvPr/>
           </p:nvSpPr>
@@ -6443,7 +6774,7 @@
         </p:sp>
         <p:sp>
           <p:nvSpPr>
-            <p:cNvPr id="5" name="Rectangle 4"/>
+            <p:cNvPr id="6" name="Rectangle 5"/>
             <p:cNvSpPr/>
             <p:nvPr/>
           </p:nvSpPr>
@@ -6489,7 +6820,7 @@
         </p:sp>
         <p:sp>
           <p:nvSpPr>
-            <p:cNvPr id="6" name="Rectangle 5"/>
+            <p:cNvPr id="7" name="Rectangle 6"/>
             <p:cNvSpPr/>
             <p:nvPr/>
           </p:nvSpPr>
@@ -6535,7 +6866,7 @@
         </p:sp>
         <p:sp>
           <p:nvSpPr>
-            <p:cNvPr id="7" name="Rectangle 6"/>
+            <p:cNvPr id="8" name="Rectangle 7"/>
             <p:cNvSpPr/>
             <p:nvPr/>
           </p:nvSpPr>
@@ -6581,7 +6912,7 @@
         </p:sp>
         <p:sp>
           <p:nvSpPr>
-            <p:cNvPr id="8" name="Rectangle 7"/>
+            <p:cNvPr id="9" name="Rectangle 8"/>
             <p:cNvSpPr/>
             <p:nvPr/>
           </p:nvSpPr>
@@ -6627,7 +6958,7 @@
         </p:sp>
         <p:sp>
           <p:nvSpPr>
-            <p:cNvPr id="9" name="TextBox 8"/>
+            <p:cNvPr id="10" name="TextBox 9"/>
             <p:cNvSpPr txBox="1"/>
             <p:nvPr/>
           </p:nvSpPr>
@@ -6662,7 +6993,7 @@
       </p:grpSp>
       <p:sp>
         <p:nvSpPr>
-          <p:cNvPr id="10" name="TextBox 9"/>
+          <p:cNvPr id="11" name="TextBox 10"/>
           <p:cNvSpPr txBox="1"/>
           <p:nvPr/>
         </p:nvSpPr>
@@ -6683,7 +7014,7 @@
           <a:lstStyle/>
           <a:p>
             <a:r>
-              <a:rPr sz="2200" b="0" i="0">
+              <a:rPr sz="2800" b="0" i="0">
                 <a:solidFill>
                   <a:srgbClr val="1B1035"/>
                 </a:solidFill>
@@ -6696,7 +7027,7 @@
       </p:sp>
       <p:sp>
         <p:nvSpPr>
-          <p:cNvPr id="11" name="TextBox 10"/>
+          <p:cNvPr id="12" name="TextBox 11"/>
           <p:cNvSpPr txBox="1"/>
           <p:nvPr/>
         </p:nvSpPr>
@@ -6767,14 +7098,40 @@
       <p:grpSpPr/>
       <p:sp>
         <p:nvSpPr>
-          <p:cNvPr id="2" name="TextBox 1"/>
+          <p:cNvPr id="2" name="Title 1"/>
+          <p:cNvSpPr>
+            <a:spLocks noGrp="1"/>
+          </p:cNvSpPr>
+          <p:nvPr>
+            <p:ph type="title"/>
+          </p:nvPr>
+        </p:nvSpPr>
+        <p:spPr>
+          <a:xfrm>
+            <a:off x="-12191695" y="0"/>
+            <a:ext cx="12191695" cy="914400"/>
+          </a:xfrm>
+        </p:spPr>
+        <p:txBody>
+          <a:bodyPr/>
+          <a:lstStyle/>
+          <a:p>
+            <a:r>
+              <a:t>Machines that write</a:t>
+            </a:r>
+          </a:p>
+        </p:txBody>
+      </p:sp>
+      <p:sp>
+        <p:nvSpPr>
+          <p:cNvPr id="3" name="TextBox 2"/>
           <p:cNvSpPr txBox="1"/>
           <p:nvPr/>
         </p:nvSpPr>
         <p:spPr>
           <a:xfrm>
-            <a:off x="731520" y="1463040"/>
-            <a:ext cx="10728655" cy="2926080"/>
+            <a:off x="274320" y="1417320"/>
+            <a:ext cx="11643055" cy="4023360"/>
           </a:xfrm>
           <a:prstGeom prst="rect">
             <a:avLst/>
@@ -6799,7 +7156,11 @@
             </a:r>
           </a:p>
           <a:p>
-            <a:pPr algn="ctr"/>
+            <a:pPr algn="ctr">
+              <a:spcBef>
+                <a:spcPts val="1000"/>
+              </a:spcBef>
+            </a:pPr>
             <a:r>
               <a:rPr sz="2800" b="0" i="0">
                 <a:solidFill>
@@ -6838,9 +7199,41 @@
         <p:nvPr/>
       </p:nvGrpSpPr>
       <p:grpSpPr/>
+      <p:sp>
+        <p:nvSpPr>
+          <p:cNvPr id="2" name="Title 1"/>
+          <p:cNvSpPr>
+            <a:spLocks noGrp="1"/>
+          </p:cNvSpPr>
+          <p:nvPr>
+            <p:ph type="title"/>
+          </p:nvPr>
+        </p:nvSpPr>
+        <p:spPr>
+          <a:xfrm>
+            <a:off x="-12191695" y="0"/>
+            <a:ext cx="12191695" cy="914400"/>
+          </a:xfrm>
+        </p:spPr>
+        <p:txBody>
+          <a:bodyPr/>
+          <a:lstStyle/>
+          <a:p>
+            <a:r>
+              <a:t>Racter's The Policeman's Beard Is Half Constructed (1984), billed as the first book written by a computer</a:t>
+            </a:r>
+          </a:p>
+        </p:txBody>
+      </p:sp>
       <p:grpSp>
         <p:nvGrpSpPr>
-          <p:cNvPr id="2" name="Group 1"/>
+          <p:cNvPr id="3" name="Window image.png">
+            <a:extLst>
+              <a:ext uri="{C183D7F6-B498-43B3-948B-1728B52AA6E4}">
+                <adec:decorative xmlns:adec="http://schemas.microsoft.com/office/drawing/2017/decorative" val="1"/>
+              </a:ext>
+            </a:extLst>
+          </p:cNvPr>
           <p:cNvGrpSpPr/>
           <p:nvPr/>
         </p:nvGrpSpPr>
@@ -6854,7 +7247,7 @@
         </p:grpSpPr>
         <p:sp>
           <p:nvSpPr>
-            <p:cNvPr id="3" name="Rectangle 2"/>
+            <p:cNvPr id="4" name="Rectangle 3"/>
             <p:cNvSpPr/>
             <p:nvPr/>
           </p:nvSpPr>
@@ -6898,7 +7291,7 @@
         </p:sp>
         <p:sp>
           <p:nvSpPr>
-            <p:cNvPr id="4" name="Rectangle 3"/>
+            <p:cNvPr id="5" name="Rectangle 4"/>
             <p:cNvSpPr/>
             <p:nvPr/>
           </p:nvSpPr>
@@ -6944,7 +7337,7 @@
         </p:sp>
         <p:sp>
           <p:nvSpPr>
-            <p:cNvPr id="5" name="Rectangle 4"/>
+            <p:cNvPr id="6" name="Rectangle 5"/>
             <p:cNvSpPr/>
             <p:nvPr/>
           </p:nvSpPr>
@@ -6990,7 +7383,7 @@
         </p:sp>
         <p:sp>
           <p:nvSpPr>
-            <p:cNvPr id="6" name="Rectangle 5"/>
+            <p:cNvPr id="7" name="Rectangle 6"/>
             <p:cNvSpPr/>
             <p:nvPr/>
           </p:nvSpPr>
@@ -7036,7 +7429,7 @@
         </p:sp>
         <p:sp>
           <p:nvSpPr>
-            <p:cNvPr id="7" name="Rectangle 6"/>
+            <p:cNvPr id="8" name="Rectangle 7"/>
             <p:cNvSpPr/>
             <p:nvPr/>
           </p:nvSpPr>
@@ -7082,7 +7475,7 @@
         </p:sp>
         <p:sp>
           <p:nvSpPr>
-            <p:cNvPr id="8" name="Rectangle 7"/>
+            <p:cNvPr id="9" name="Rectangle 8"/>
             <p:cNvSpPr/>
             <p:nvPr/>
           </p:nvSpPr>
@@ -7128,7 +7521,7 @@
         </p:sp>
         <p:sp>
           <p:nvSpPr>
-            <p:cNvPr id="9" name="TextBox 8"/>
+            <p:cNvPr id="10" name="TextBox 9"/>
             <p:cNvSpPr txBox="1"/>
             <p:nvPr/>
           </p:nvSpPr>
@@ -7163,7 +7556,7 @@
       </p:grpSp>
       <p:pic>
         <p:nvPicPr>
-          <p:cNvPr id="10" name="Picture 9" descr="Red book cover reading 'The Policeman's Beard Is Half Constructed: Computer prose and poetry by Racter,' with a collage portrait and the tagline 'The First Book Ever Written by a Computer.'"/>
+          <p:cNvPr id="11" name="Picture 10" descr="Red book cover reading 'The Policeman's Beard Is Half Constructed: Computer prose and poetry by Racter,' with a collage portrait and the tagline 'The First Book Ever Written by a Computer.'"/>
           <p:cNvPicPr>
             <a:picLocks noChangeAspect="1"/>
           </p:cNvPicPr>
@@ -7187,13 +7580,13 @@
       </p:pic>
       <p:sp>
         <p:nvSpPr>
-          <p:cNvPr id="11" name="TextBox 10"/>
+          <p:cNvPr id="12" name="TextBox 11"/>
           <p:cNvSpPr txBox="1"/>
           <p:nvPr/>
         </p:nvSpPr>
         <p:spPr>
           <a:xfrm>
-            <a:off x="822960" y="5989320"/>
+            <a:off x="822960" y="5943600"/>
             <a:ext cx="10545775" cy="731520"/>
           </a:xfrm>
           <a:prstGeom prst="rect">
@@ -7209,7 +7602,7 @@
           <a:p>
             <a:pPr algn="ctr"/>
             <a:r>
-              <a:rPr sz="1800" b="0" i="0">
+              <a:rPr sz="1600" b="0" i="0">
                 <a:solidFill>
                   <a:srgbClr val="1B1035"/>
                 </a:solidFill>
@@ -7218,7 +7611,7 @@
               <a:t>Racter's </a:t>
             </a:r>
             <a:r>
-              <a:rPr sz="1800" b="0" i="1">
+              <a:rPr sz="1600" b="0" i="1">
                 <a:solidFill>
                   <a:srgbClr val="1B1035"/>
                 </a:solidFill>
@@ -7227,7 +7620,7 @@
               <a:t>The Policeman's Beard Is Half Constructed</a:t>
             </a:r>
             <a:r>
-              <a:rPr sz="1800" b="0" i="0">
+              <a:rPr sz="1600" b="0" i="0">
                 <a:solidFill>
                   <a:srgbClr val="1B1035"/>
                 </a:solidFill>
@@ -7264,9 +7657,41 @@
         <p:nvPr/>
       </p:nvGrpSpPr>
       <p:grpSpPr/>
+      <p:sp>
+        <p:nvSpPr>
+          <p:cNvPr id="2" name="Title 1"/>
+          <p:cNvSpPr>
+            <a:spLocks noGrp="1"/>
+          </p:cNvSpPr>
+          <p:nvPr>
+            <p:ph type="title"/>
+          </p:nvPr>
+        </p:nvSpPr>
+        <p:spPr>
+          <a:xfrm>
+            <a:off x="-12191695" y="0"/>
+            <a:ext cx="12191695" cy="914400"/>
+          </a:xfrm>
+        </p:spPr>
+        <p:txBody>
+          <a:bodyPr/>
+          <a:lstStyle/>
+          <a:p>
+            <a:r>
+              <a:t>Racter talks about itself, 1980s style</a:t>
+            </a:r>
+          </a:p>
+        </p:txBody>
+      </p:sp>
       <p:grpSp>
         <p:nvGrpSpPr>
-          <p:cNvPr id="2" name="Group 1"/>
+          <p:cNvPr id="3" name="Window image.png">
+            <a:extLst>
+              <a:ext uri="{C183D7F6-B498-43B3-948B-1728B52AA6E4}">
+                <adec:decorative xmlns:adec="http://schemas.microsoft.com/office/drawing/2017/decorative" val="1"/>
+              </a:ext>
+            </a:extLst>
+          </p:cNvPr>
           <p:cNvGrpSpPr/>
           <p:nvPr/>
         </p:nvGrpSpPr>
@@ -7280,7 +7705,7 @@
         </p:grpSpPr>
         <p:sp>
           <p:nvSpPr>
-            <p:cNvPr id="3" name="Rectangle 2"/>
+            <p:cNvPr id="4" name="Rectangle 3"/>
             <p:cNvSpPr/>
             <p:nvPr/>
           </p:nvSpPr>
@@ -7324,7 +7749,7 @@
         </p:sp>
         <p:sp>
           <p:nvSpPr>
-            <p:cNvPr id="4" name="Rectangle 3"/>
+            <p:cNvPr id="5" name="Rectangle 4"/>
             <p:cNvSpPr/>
             <p:nvPr/>
           </p:nvSpPr>
@@ -7370,7 +7795,7 @@
         </p:sp>
         <p:sp>
           <p:nvSpPr>
-            <p:cNvPr id="5" name="Rectangle 4"/>
+            <p:cNvPr id="6" name="Rectangle 5"/>
             <p:cNvSpPr/>
             <p:nvPr/>
           </p:nvSpPr>
@@ -7416,7 +7841,7 @@
         </p:sp>
         <p:sp>
           <p:nvSpPr>
-            <p:cNvPr id="6" name="Rectangle 5"/>
+            <p:cNvPr id="7" name="Rectangle 6"/>
             <p:cNvSpPr/>
             <p:nvPr/>
           </p:nvSpPr>
@@ -7462,7 +7887,7 @@
         </p:sp>
         <p:sp>
           <p:nvSpPr>
-            <p:cNvPr id="7" name="Rectangle 6"/>
+            <p:cNvPr id="8" name="Rectangle 7"/>
             <p:cNvSpPr/>
             <p:nvPr/>
           </p:nvSpPr>
@@ -7508,7 +7933,7 @@
         </p:sp>
         <p:sp>
           <p:nvSpPr>
-            <p:cNvPr id="8" name="Rectangle 7"/>
+            <p:cNvPr id="9" name="Rectangle 8"/>
             <p:cNvSpPr/>
             <p:nvPr/>
           </p:nvSpPr>
@@ -7554,7 +7979,7 @@
         </p:sp>
         <p:sp>
           <p:nvSpPr>
-            <p:cNvPr id="9" name="TextBox 8"/>
+            <p:cNvPr id="10" name="TextBox 9"/>
             <p:cNvSpPr txBox="1"/>
             <p:nvPr/>
           </p:nvSpPr>
@@ -7589,7 +8014,7 @@
       </p:grpSp>
       <p:pic>
         <p:nvPicPr>
-          <p:cNvPr id="10" name="Picture 9" descr="Black screen of white monospaced text in which the program muses 'I am a computer, not some lamb or chicken or beef. Can I skip to my attourney?'"/>
+          <p:cNvPr id="11" name="Picture 10" descr="Black screen of white monospaced text in which the program muses 'I am a computer, not some lamb or chicken or beef. Can I skip to my attourney?'"/>
           <p:cNvPicPr>
             <a:picLocks noChangeAspect="1"/>
           </p:cNvPicPr>
@@ -7613,13 +8038,13 @@
       </p:pic>
       <p:sp>
         <p:nvSpPr>
-          <p:cNvPr id="11" name="TextBox 10"/>
+          <p:cNvPr id="12" name="TextBox 11"/>
           <p:cNvSpPr txBox="1"/>
           <p:nvPr/>
         </p:nvSpPr>
         <p:spPr>
           <a:xfrm>
-            <a:off x="822960" y="5989320"/>
+            <a:off x="822960" y="5943600"/>
             <a:ext cx="10545775" cy="731520"/>
           </a:xfrm>
           <a:prstGeom prst="rect">
@@ -7682,9 +8107,41 @@
         <p:nvPr/>
       </p:nvGrpSpPr>
       <p:grpSpPr/>
+      <p:sp>
+        <p:nvSpPr>
+          <p:cNvPr id="2" name="Title 1"/>
+          <p:cNvSpPr>
+            <a:spLocks noGrp="1"/>
+          </p:cNvSpPr>
+          <p:nvPr>
+            <p:ph type="title"/>
+          </p:nvPr>
+        </p:nvSpPr>
+        <p:spPr>
+          <a:xfrm>
+            <a:off x="-12191695" y="0"/>
+            <a:ext cx="12191695" cy="914400"/>
+          </a:xfrm>
+        </p:spPr>
+        <p:txBody>
+          <a:bodyPr/>
+          <a:lstStyle/>
+          <a:p>
+            <a:r>
+              <a:t>Kasparov vs. IBM's Deep Blue, 1997: AI as a contest with humans</a:t>
+            </a:r>
+          </a:p>
+        </p:txBody>
+      </p:sp>
       <p:grpSp>
         <p:nvGrpSpPr>
-          <p:cNvPr id="2" name="Group 1"/>
+          <p:cNvPr id="3" name="Window image.png">
+            <a:extLst>
+              <a:ext uri="{C183D7F6-B498-43B3-948B-1728B52AA6E4}">
+                <adec:decorative xmlns:adec="http://schemas.microsoft.com/office/drawing/2017/decorative" val="1"/>
+              </a:ext>
+            </a:extLst>
+          </p:cNvPr>
           <p:cNvGrpSpPr/>
           <p:nvPr/>
         </p:nvGrpSpPr>
@@ -7698,7 +8155,7 @@
         </p:grpSpPr>
         <p:sp>
           <p:nvSpPr>
-            <p:cNvPr id="3" name="Rectangle 2"/>
+            <p:cNvPr id="4" name="Rectangle 3"/>
             <p:cNvSpPr/>
             <p:nvPr/>
           </p:nvSpPr>
@@ -7742,7 +8199,7 @@
         </p:sp>
         <p:sp>
           <p:nvSpPr>
-            <p:cNvPr id="4" name="Rectangle 3"/>
+            <p:cNvPr id="5" name="Rectangle 4"/>
             <p:cNvSpPr/>
             <p:nvPr/>
           </p:nvSpPr>
@@ -7788,7 +8245,7 @@
         </p:sp>
         <p:sp>
           <p:nvSpPr>
-            <p:cNvPr id="5" name="Rectangle 4"/>
+            <p:cNvPr id="6" name="Rectangle 5"/>
             <p:cNvSpPr/>
             <p:nvPr/>
           </p:nvSpPr>
@@ -7834,7 +8291,7 @@
         </p:sp>
         <p:sp>
           <p:nvSpPr>
-            <p:cNvPr id="6" name="Rectangle 5"/>
+            <p:cNvPr id="7" name="Rectangle 6"/>
             <p:cNvSpPr/>
             <p:nvPr/>
           </p:nvSpPr>
@@ -7880,7 +8337,7 @@
         </p:sp>
         <p:sp>
           <p:nvSpPr>
-            <p:cNvPr id="7" name="Rectangle 6"/>
+            <p:cNvPr id="8" name="Rectangle 7"/>
             <p:cNvSpPr/>
             <p:nvPr/>
           </p:nvSpPr>
@@ -7926,7 +8383,7 @@
         </p:sp>
         <p:sp>
           <p:nvSpPr>
-            <p:cNvPr id="8" name="Rectangle 7"/>
+            <p:cNvPr id="9" name="Rectangle 8"/>
             <p:cNvSpPr/>
             <p:nvPr/>
           </p:nvSpPr>
@@ -7972,7 +8429,7 @@
         </p:sp>
         <p:sp>
           <p:nvSpPr>
-            <p:cNvPr id="9" name="TextBox 8"/>
+            <p:cNvPr id="10" name="TextBox 9"/>
             <p:cNvSpPr txBox="1"/>
             <p:nvPr/>
           </p:nvSpPr>
@@ -8007,7 +8464,7 @@
       </p:grpSp>
       <p:pic>
         <p:nvPicPr>
-          <p:cNvPr id="10" name="Picture 9" descr="Article header '20 Years after Deep Blue: How AI Has Advanced Since Conquering Chess' above a photo of Garry Kasparov leaning over a chessboard."/>
+          <p:cNvPr id="11" name="Picture 10" descr="Article header '20 Years after Deep Blue: How AI Has Advanced Since Conquering Chess' above a photo of Garry Kasparov leaning over a chessboard."/>
           <p:cNvPicPr>
             <a:picLocks noChangeAspect="1"/>
           </p:cNvPicPr>
@@ -8031,13 +8488,13 @@
       </p:pic>
       <p:sp>
         <p:nvSpPr>
-          <p:cNvPr id="11" name="TextBox 10"/>
+          <p:cNvPr id="12" name="TextBox 11"/>
           <p:cNvSpPr txBox="1"/>
           <p:nvPr/>
         </p:nvSpPr>
         <p:spPr>
           <a:xfrm>
-            <a:off x="822960" y="5989320"/>
+            <a:off x="822960" y="5943600"/>
             <a:ext cx="10545775" cy="731520"/>
           </a:xfrm>
           <a:prstGeom prst="rect">
@@ -8092,7 +8549,33 @@
       <p:grpSpPr/>
       <p:sp>
         <p:nvSpPr>
-          <p:cNvPr id="2" name="TextBox 1"/>
+          <p:cNvPr id="2" name="Title 1"/>
+          <p:cNvSpPr>
+            <a:spLocks noGrp="1"/>
+          </p:cNvSpPr>
+          <p:nvPr>
+            <p:ph type="title"/>
+          </p:nvPr>
+        </p:nvSpPr>
+        <p:spPr>
+          <a:xfrm>
+            <a:off x="-12191695" y="0"/>
+            <a:ext cx="12191695" cy="914400"/>
+          </a:xfrm>
+        </p:spPr>
+        <p:txBody>
+          <a:bodyPr/>
+          <a:lstStyle/>
+          <a:p>
+            <a:r>
+              <a:t>Readings</a:t>
+            </a:r>
+          </a:p>
+        </p:txBody>
+      </p:sp>
+      <p:sp>
+        <p:nvSpPr>
+          <p:cNvPr id="3" name="TextBox 2"/>
           <p:cNvSpPr txBox="1"/>
           <p:nvPr/>
         </p:nvSpPr>
@@ -8126,7 +8609,7 @@
       </p:sp>
       <p:sp>
         <p:nvSpPr>
-          <p:cNvPr id="3" name="TextBox 2"/>
+          <p:cNvPr id="4" name="TextBox 3"/>
           <p:cNvSpPr txBox="1"/>
           <p:nvPr/>
         </p:nvSpPr>
@@ -8187,7 +8670,7 @@
                 </a:solidFill>
                 <a:latin typeface="Verdana"/>
               </a:rPr>
-              <a:t>— a short, classic introduction to the field</a:t>
+              <a:t> — a short, classic introduction to the field</a:t>
             </a:r>
           </a:p>
           <a:p>
@@ -8250,7 +8733,7 @@
                 </a:solidFill>
                 <a:latin typeface="Verdana"/>
               </a:rPr>
-              <a:t>— podcast + transcript: the first chatbot and the people who talked to it</a:t>
+              <a:t> — podcast + transcript: the first chatbot and the people who talked to it</a:t>
             </a:r>
           </a:p>
         </p:txBody>
@@ -8281,9 +8764,41 @@
         <p:nvPr/>
       </p:nvGrpSpPr>
       <p:grpSpPr/>
+      <p:sp>
+        <p:nvSpPr>
+          <p:cNvPr id="2" name="Title 1"/>
+          <p:cNvSpPr>
+            <a:spLocks noGrp="1"/>
+          </p:cNvSpPr>
+          <p:nvPr>
+            <p:ph type="title"/>
+          </p:nvPr>
+        </p:nvSpPr>
+        <p:spPr>
+          <a:xfrm>
+            <a:off x="-12191695" y="0"/>
+            <a:ext cx="12191695" cy="914400"/>
+          </a:xfrm>
+        </p:spPr>
+        <p:txBody>
+          <a:bodyPr/>
+          <a:lstStyle/>
+          <a:p>
+            <a:r>
+              <a:t>Quote: Delaney Hall, “The ELIZA Effect”</a:t>
+            </a:r>
+          </a:p>
+        </p:txBody>
+      </p:sp>
       <p:grpSp>
         <p:nvGrpSpPr>
-          <p:cNvPr id="2" name="Group 1"/>
+          <p:cNvPr id="3" name="Window quote.txt">
+            <a:extLst>
+              <a:ext uri="{C183D7F6-B498-43B3-948B-1728B52AA6E4}">
+                <adec:decorative xmlns:adec="http://schemas.microsoft.com/office/drawing/2017/decorative" val="1"/>
+              </a:ext>
+            </a:extLst>
+          </p:cNvPr>
           <p:cNvGrpSpPr/>
           <p:nvPr/>
         </p:nvGrpSpPr>
@@ -8297,7 +8812,7 @@
         </p:grpSpPr>
         <p:sp>
           <p:nvSpPr>
-            <p:cNvPr id="3" name="Rectangle 2"/>
+            <p:cNvPr id="4" name="Rectangle 3"/>
             <p:cNvSpPr/>
             <p:nvPr/>
           </p:nvSpPr>
@@ -8341,7 +8856,7 @@
         </p:sp>
         <p:sp>
           <p:nvSpPr>
-            <p:cNvPr id="4" name="Rectangle 3"/>
+            <p:cNvPr id="5" name="Rectangle 4"/>
             <p:cNvSpPr/>
             <p:nvPr/>
           </p:nvSpPr>
@@ -8387,7 +8902,7 @@
         </p:sp>
         <p:sp>
           <p:nvSpPr>
-            <p:cNvPr id="5" name="Rectangle 4"/>
+            <p:cNvPr id="6" name="Rectangle 5"/>
             <p:cNvSpPr/>
             <p:nvPr/>
           </p:nvSpPr>
@@ -8433,7 +8948,7 @@
         </p:sp>
         <p:sp>
           <p:nvSpPr>
-            <p:cNvPr id="6" name="Rectangle 5"/>
+            <p:cNvPr id="7" name="Rectangle 6"/>
             <p:cNvSpPr/>
             <p:nvPr/>
           </p:nvSpPr>
@@ -8479,7 +8994,7 @@
         </p:sp>
         <p:sp>
           <p:nvSpPr>
-            <p:cNvPr id="7" name="Rectangle 6"/>
+            <p:cNvPr id="8" name="Rectangle 7"/>
             <p:cNvSpPr/>
             <p:nvPr/>
           </p:nvSpPr>
@@ -8525,7 +9040,7 @@
         </p:sp>
         <p:sp>
           <p:nvSpPr>
-            <p:cNvPr id="8" name="Rectangle 7"/>
+            <p:cNvPr id="9" name="Rectangle 8"/>
             <p:cNvSpPr/>
             <p:nvPr/>
           </p:nvSpPr>
@@ -8571,7 +9086,7 @@
         </p:sp>
         <p:sp>
           <p:nvSpPr>
-            <p:cNvPr id="9" name="TextBox 8"/>
+            <p:cNvPr id="10" name="TextBox 9"/>
             <p:cNvSpPr txBox="1"/>
             <p:nvPr/>
           </p:nvSpPr>
@@ -8606,7 +9121,7 @@
       </p:grpSp>
       <p:sp>
         <p:nvSpPr>
-          <p:cNvPr id="10" name="TextBox 9"/>
+          <p:cNvPr id="11" name="TextBox 10"/>
           <p:cNvSpPr txBox="1"/>
           <p:nvPr/>
         </p:nvSpPr>
@@ -8627,7 +9142,7 @@
           <a:lstStyle/>
           <a:p>
             <a:r>
-              <a:rPr sz="2200" b="0" i="0">
+              <a:rPr sz="2800" b="0" i="0">
                 <a:solidFill>
                   <a:srgbClr val="1B1035"/>
                 </a:solidFill>
@@ -8640,7 +9155,7 @@
       </p:sp>
       <p:sp>
         <p:nvSpPr>
-          <p:cNvPr id="11" name="TextBox 10"/>
+          <p:cNvPr id="12" name="TextBox 11"/>
           <p:cNvSpPr txBox="1"/>
           <p:nvPr/>
         </p:nvSpPr>
@@ -8711,14 +9226,40 @@
       <p:grpSpPr/>
       <p:sp>
         <p:nvSpPr>
-          <p:cNvPr id="2" name="TextBox 1"/>
+          <p:cNvPr id="2" name="Title 1"/>
+          <p:cNvSpPr>
+            <a:spLocks noGrp="1"/>
+          </p:cNvSpPr>
+          <p:nvPr>
+            <p:ph type="title"/>
+          </p:nvPr>
+        </p:nvSpPr>
+        <p:spPr>
+          <a:xfrm>
+            <a:off x="-12191695" y="0"/>
+            <a:ext cx="12191695" cy="914400"/>
+          </a:xfrm>
+        </p:spPr>
+        <p:txBody>
+          <a:bodyPr/>
+          <a:lstStyle/>
+          <a:p>
+            <a:r>
+              <a:t>Next week, Do: Talking to Chatbots, Then and Now</a:t>
+            </a:r>
+          </a:p>
+        </p:txBody>
+      </p:sp>
+      <p:sp>
+        <p:nvSpPr>
+          <p:cNvPr id="3" name="TextBox 2"/>
           <p:cNvSpPr txBox="1"/>
           <p:nvPr/>
         </p:nvSpPr>
         <p:spPr>
           <a:xfrm>
-            <a:off x="731520" y="1463040"/>
-            <a:ext cx="10728655" cy="2926080"/>
+            <a:off x="274320" y="1417320"/>
+            <a:ext cx="11643055" cy="4023360"/>
           </a:xfrm>
           <a:prstGeom prst="rect">
             <a:avLst/>
@@ -8733,19 +9274,33 @@
           <a:p>
             <a:pPr algn="ctr"/>
             <a:r>
-              <a:rPr sz="5400" b="0" i="0">
+              <a:rPr sz="4400" b="0" i="0">
                 <a:solidFill>
                   <a:srgbClr val="FFFFFF"/>
                 </a:solidFill>
                 <a:latin typeface="Arial Black"/>
               </a:rPr>
-              <a:t>Next week, Do: Talking to Chatbots, Then and Now</a:t>
-            </a:r>
-          </a:p>
-          <a:p>
-            <a:pPr algn="ctr"/>
-            <a:r>
-              <a:rPr sz="2800" b="0" i="0">
+              <a:t>Next week, Do:</a:t>
+            </a:r>
+            <a:br/>
+            <a:r>
+              <a:rPr sz="4400" b="0" i="0">
+                <a:solidFill>
+                  <a:srgbClr val="FFFFFF"/>
+                </a:solidFill>
+                <a:latin typeface="Arial Black"/>
+              </a:rPr>
+              <a:t>Talking to Chatbots, Then and Now</a:t>
+            </a:r>
+          </a:p>
+          <a:p>
+            <a:pPr algn="ctr">
+              <a:spcBef>
+                <a:spcPts val="1000"/>
+              </a:spcBef>
+            </a:pPr>
+            <a:r>
+              <a:rPr sz="2400" b="0" i="0">
                 <a:solidFill>
                   <a:srgbClr val="FFFFFF"/>
                 </a:solidFill>
@@ -8784,7 +9339,33 @@
       <p:grpSpPr/>
       <p:sp>
         <p:nvSpPr>
-          <p:cNvPr id="2" name="TextBox 1"/>
+          <p:cNvPr id="2" name="Title 1"/>
+          <p:cNvSpPr>
+            <a:spLocks noGrp="1"/>
+          </p:cNvSpPr>
+          <p:nvPr>
+            <p:ph type="title"/>
+          </p:nvPr>
+        </p:nvSpPr>
+        <p:spPr>
+          <a:xfrm>
+            <a:off x="-12191695" y="0"/>
+            <a:ext cx="12191695" cy="914400"/>
+          </a:xfrm>
+        </p:spPr>
+        <p:txBody>
+          <a:bodyPr/>
+          <a:lstStyle/>
+          <a:p>
+            <a:r>
+              <a:t>Three conversations</a:t>
+            </a:r>
+          </a:p>
+        </p:txBody>
+      </p:sp>
+      <p:sp>
+        <p:nvSpPr>
+          <p:cNvPr id="3" name="TextBox 2"/>
           <p:cNvSpPr txBox="1"/>
           <p:nvPr/>
         </p:nvSpPr>
@@ -8818,7 +9399,7 @@
       </p:sp>
       <p:sp>
         <p:nvSpPr>
-          <p:cNvPr id="3" name="TextBox 2"/>
+          <p:cNvPr id="4" name="TextBox 3"/>
           <p:cNvSpPr txBox="1"/>
           <p:nvPr/>
         </p:nvSpPr>
@@ -9016,9 +9597,41 @@
         <p:nvPr/>
       </p:nvGrpSpPr>
       <p:grpSpPr/>
+      <p:sp>
+        <p:nvSpPr>
+          <p:cNvPr id="2" name="Title 1"/>
+          <p:cNvSpPr>
+            <a:spLocks noGrp="1"/>
+          </p:cNvSpPr>
+          <p:nvPr>
+            <p:ph type="title"/>
+          </p:nvPr>
+        </p:nvSpPr>
+        <p:spPr>
+          <a:xfrm>
+            <a:off x="-12191695" y="0"/>
+            <a:ext cx="12191695" cy="914400"/>
+          </a:xfrm>
+        </p:spPr>
+        <p:txBody>
+          <a:bodyPr/>
+          <a:lstStyle/>
+          <a:p>
+            <a:r>
+              <a:t>Prompt: conversation two, starting prompt</a:t>
+            </a:r>
+          </a:p>
+        </p:txBody>
+      </p:sp>
       <p:grpSp>
         <p:nvGrpSpPr>
-          <p:cNvPr id="2" name="Group 1"/>
+          <p:cNvPr id="3" name="Window prompt.exe">
+            <a:extLst>
+              <a:ext uri="{C183D7F6-B498-43B3-948B-1728B52AA6E4}">
+                <adec:decorative xmlns:adec="http://schemas.microsoft.com/office/drawing/2017/decorative" val="1"/>
+              </a:ext>
+            </a:extLst>
+          </p:cNvPr>
           <p:cNvGrpSpPr/>
           <p:nvPr/>
         </p:nvGrpSpPr>
@@ -9032,7 +9645,7 @@
         </p:grpSpPr>
         <p:sp>
           <p:nvSpPr>
-            <p:cNvPr id="3" name="Rectangle 2"/>
+            <p:cNvPr id="4" name="Rectangle 3"/>
             <p:cNvSpPr/>
             <p:nvPr/>
           </p:nvSpPr>
@@ -9076,7 +9689,7 @@
         </p:sp>
         <p:sp>
           <p:nvSpPr>
-            <p:cNvPr id="4" name="Rectangle 3"/>
+            <p:cNvPr id="5" name="Rectangle 4"/>
             <p:cNvSpPr/>
             <p:nvPr/>
           </p:nvSpPr>
@@ -9122,7 +9735,7 @@
         </p:sp>
         <p:sp>
           <p:nvSpPr>
-            <p:cNvPr id="5" name="Rectangle 4"/>
+            <p:cNvPr id="6" name="Rectangle 5"/>
             <p:cNvSpPr/>
             <p:nvPr/>
           </p:nvSpPr>
@@ -9168,7 +9781,7 @@
         </p:sp>
         <p:sp>
           <p:nvSpPr>
-            <p:cNvPr id="6" name="Rectangle 5"/>
+            <p:cNvPr id="7" name="Rectangle 6"/>
             <p:cNvSpPr/>
             <p:nvPr/>
           </p:nvSpPr>
@@ -9214,7 +9827,7 @@
         </p:sp>
         <p:sp>
           <p:nvSpPr>
-            <p:cNvPr id="7" name="Rectangle 6"/>
+            <p:cNvPr id="8" name="Rectangle 7"/>
             <p:cNvSpPr/>
             <p:nvPr/>
           </p:nvSpPr>
@@ -9260,7 +9873,7 @@
         </p:sp>
         <p:sp>
           <p:nvSpPr>
-            <p:cNvPr id="8" name="Rectangle 7"/>
+            <p:cNvPr id="9" name="Rectangle 8"/>
             <p:cNvSpPr/>
             <p:nvPr/>
           </p:nvSpPr>
@@ -9306,7 +9919,7 @@
         </p:sp>
         <p:sp>
           <p:nvSpPr>
-            <p:cNvPr id="9" name="TextBox 8"/>
+            <p:cNvPr id="10" name="TextBox 9"/>
             <p:cNvSpPr txBox="1"/>
             <p:nvPr/>
           </p:nvSpPr>
@@ -9341,7 +9954,7 @@
       </p:grpSp>
       <p:sp>
         <p:nvSpPr>
-          <p:cNvPr id="10" name="TextBox 9"/>
+          <p:cNvPr id="11" name="TextBox 10"/>
           <p:cNvSpPr txBox="1"/>
           <p:nvPr/>
         </p:nvSpPr>
@@ -9372,6 +9985,11 @@
             </a:r>
           </a:p>
           <a:p>
+            <a:pPr>
+              <a:spcBef>
+                <a:spcPts val="600"/>
+              </a:spcBef>
+            </a:pPr>
             <a:r>
               <a:rPr sz="2800" b="1" i="0">
                 <a:solidFill>
@@ -9379,7 +9997,7 @@
                 </a:solidFill>
                 <a:latin typeface="Courier New"/>
               </a:rPr>
-              <a:t>&gt;</a:t>
+              <a:t>&gt; </a:t>
             </a:r>
             <a:r>
               <a:rPr sz="2800" b="0" i="0">
@@ -9419,9 +10037,41 @@
         <p:nvPr/>
       </p:nvGrpSpPr>
       <p:grpSpPr/>
+      <p:sp>
+        <p:nvSpPr>
+          <p:cNvPr id="2" name="Title 1"/>
+          <p:cNvSpPr>
+            <a:spLocks noGrp="1"/>
+          </p:cNvSpPr>
+          <p:nvPr>
+            <p:ph type="title"/>
+          </p:nvPr>
+        </p:nvSpPr>
+        <p:spPr>
+          <a:xfrm>
+            <a:off x="-12191695" y="0"/>
+            <a:ext cx="12191695" cy="914400"/>
+          </a:xfrm>
+        </p:spPr>
+        <p:txBody>
+          <a:bodyPr/>
+          <a:lstStyle/>
+          <a:p>
+            <a:r>
+              <a:t>Future ELIZA: made by prompting Claude, with no AI running behind the page</a:t>
+            </a:r>
+          </a:p>
+        </p:txBody>
+      </p:sp>
       <p:grpSp>
         <p:nvGrpSpPr>
-          <p:cNvPr id="2" name="Group 1"/>
+          <p:cNvPr id="3" name="Window image.png">
+            <a:extLst>
+              <a:ext uri="{C183D7F6-B498-43B3-948B-1728B52AA6E4}">
+                <adec:decorative xmlns:adec="http://schemas.microsoft.com/office/drawing/2017/decorative" val="1"/>
+              </a:ext>
+            </a:extLst>
+          </p:cNvPr>
           <p:cNvGrpSpPr/>
           <p:nvPr/>
         </p:nvGrpSpPr>
@@ -9435,7 +10085,7 @@
         </p:grpSpPr>
         <p:sp>
           <p:nvSpPr>
-            <p:cNvPr id="3" name="Rectangle 2"/>
+            <p:cNvPr id="4" name="Rectangle 3"/>
             <p:cNvSpPr/>
             <p:nvPr/>
           </p:nvSpPr>
@@ -9479,7 +10129,7 @@
         </p:sp>
         <p:sp>
           <p:nvSpPr>
-            <p:cNvPr id="4" name="Rectangle 3"/>
+            <p:cNvPr id="5" name="Rectangle 4"/>
             <p:cNvSpPr/>
             <p:nvPr/>
           </p:nvSpPr>
@@ -9525,7 +10175,7 @@
         </p:sp>
         <p:sp>
           <p:nvSpPr>
-            <p:cNvPr id="5" name="Rectangle 4"/>
+            <p:cNvPr id="6" name="Rectangle 5"/>
             <p:cNvSpPr/>
             <p:nvPr/>
           </p:nvSpPr>
@@ -9571,7 +10221,7 @@
         </p:sp>
         <p:sp>
           <p:nvSpPr>
-            <p:cNvPr id="6" name="Rectangle 5"/>
+            <p:cNvPr id="7" name="Rectangle 6"/>
             <p:cNvSpPr/>
             <p:nvPr/>
           </p:nvSpPr>
@@ -9617,7 +10267,7 @@
         </p:sp>
         <p:sp>
           <p:nvSpPr>
-            <p:cNvPr id="7" name="Rectangle 6"/>
+            <p:cNvPr id="8" name="Rectangle 7"/>
             <p:cNvSpPr/>
             <p:nvPr/>
           </p:nvSpPr>
@@ -9663,7 +10313,7 @@
         </p:sp>
         <p:sp>
           <p:nvSpPr>
-            <p:cNvPr id="8" name="Rectangle 7"/>
+            <p:cNvPr id="9" name="Rectangle 8"/>
             <p:cNvSpPr/>
             <p:nvPr/>
           </p:nvSpPr>
@@ -9709,7 +10359,7 @@
         </p:sp>
         <p:sp>
           <p:nvSpPr>
-            <p:cNvPr id="9" name="TextBox 8"/>
+            <p:cNvPr id="10" name="TextBox 9"/>
             <p:cNvSpPr txBox="1"/>
             <p:nvPr/>
           </p:nvSpPr>
@@ -9744,7 +10394,7 @@
       </p:grpSp>
       <p:pic>
         <p:nvPicPr>
-          <p:cNvPr id="10" name="Picture 9" descr="Dark web page titled 'Future ELIZA - AI Assistant from 2045' with a chat bubble beginning 'Greetings from the year 2045!' and a 'Send to Future' button."/>
+          <p:cNvPr id="11" name="Picture 10" descr="Dark web page titled 'Future ELIZA - AI Assistant from 2045' with a chat bubble beginning 'Greetings from the year 2045!' and a 'Send to Future' button."/>
           <p:cNvPicPr>
             <a:picLocks noChangeAspect="1"/>
           </p:cNvPicPr>
@@ -9768,13 +10418,13 @@
       </p:pic>
       <p:sp>
         <p:nvSpPr>
-          <p:cNvPr id="11" name="TextBox 10"/>
+          <p:cNvPr id="12" name="TextBox 11"/>
           <p:cNvSpPr txBox="1"/>
           <p:nvPr/>
         </p:nvSpPr>
         <p:spPr>
           <a:xfrm>
-            <a:off x="822960" y="5989320"/>
+            <a:off x="822960" y="5943600"/>
             <a:ext cx="10545775" cy="731520"/>
           </a:xfrm>
           <a:prstGeom prst="rect">
@@ -9827,9 +10477,41 @@
         <p:nvPr/>
       </p:nvGrpSpPr>
       <p:grpSpPr/>
+      <p:sp>
+        <p:nvSpPr>
+          <p:cNvPr id="2" name="Title 1"/>
+          <p:cNvSpPr>
+            <a:spLocks noGrp="1"/>
+          </p:cNvSpPr>
+          <p:nvPr>
+            <p:ph type="title"/>
+          </p:nvPr>
+        </p:nvSpPr>
+        <p:spPr>
+          <a:xfrm>
+            <a:off x="-12191695" y="0"/>
+            <a:ext cx="12191695" cy="914400"/>
+          </a:xfrm>
+        </p:spPr>
+        <p:txBody>
+          <a:bodyPr/>
+          <a:lstStyle/>
+          <a:p>
+            <a:r>
+              <a:t>Discussion question</a:t>
+            </a:r>
+          </a:p>
+        </p:txBody>
+      </p:sp>
       <p:grpSp>
         <p:nvGrpSpPr>
-          <p:cNvPr id="2" name="Group 1"/>
+          <p:cNvPr id="3" name="Window discuss.txt">
+            <a:extLst>
+              <a:ext uri="{C183D7F6-B498-43B3-948B-1728B52AA6E4}">
+                <adec:decorative xmlns:adec="http://schemas.microsoft.com/office/drawing/2017/decorative" val="1"/>
+              </a:ext>
+            </a:extLst>
+          </p:cNvPr>
           <p:cNvGrpSpPr/>
           <p:nvPr/>
         </p:nvGrpSpPr>
@@ -9843,7 +10525,7 @@
         </p:grpSpPr>
         <p:sp>
           <p:nvSpPr>
-            <p:cNvPr id="3" name="Rectangle 2"/>
+            <p:cNvPr id="4" name="Rectangle 3"/>
             <p:cNvSpPr/>
             <p:nvPr/>
           </p:nvSpPr>
@@ -9887,7 +10569,7 @@
         </p:sp>
         <p:sp>
           <p:nvSpPr>
-            <p:cNvPr id="4" name="Rectangle 3"/>
+            <p:cNvPr id="5" name="Rectangle 4"/>
             <p:cNvSpPr/>
             <p:nvPr/>
           </p:nvSpPr>
@@ -9933,7 +10615,7 @@
         </p:sp>
         <p:sp>
           <p:nvSpPr>
-            <p:cNvPr id="5" name="Rectangle 4"/>
+            <p:cNvPr id="6" name="Rectangle 5"/>
             <p:cNvSpPr/>
             <p:nvPr/>
           </p:nvSpPr>
@@ -9979,7 +10661,7 @@
         </p:sp>
         <p:sp>
           <p:nvSpPr>
-            <p:cNvPr id="6" name="Rectangle 5"/>
+            <p:cNvPr id="7" name="Rectangle 6"/>
             <p:cNvSpPr/>
             <p:nvPr/>
           </p:nvSpPr>
@@ -10025,7 +10707,7 @@
         </p:sp>
         <p:sp>
           <p:nvSpPr>
-            <p:cNvPr id="7" name="Rectangle 6"/>
+            <p:cNvPr id="8" name="Rectangle 7"/>
             <p:cNvSpPr/>
             <p:nvPr/>
           </p:nvSpPr>
@@ -10071,7 +10753,7 @@
         </p:sp>
         <p:sp>
           <p:nvSpPr>
-            <p:cNvPr id="8" name="Rectangle 7"/>
+            <p:cNvPr id="9" name="Rectangle 8"/>
             <p:cNvSpPr/>
             <p:nvPr/>
           </p:nvSpPr>
@@ -10117,7 +10799,7 @@
         </p:sp>
         <p:sp>
           <p:nvSpPr>
-            <p:cNvPr id="9" name="TextBox 8"/>
+            <p:cNvPr id="10" name="TextBox 9"/>
             <p:cNvSpPr txBox="1"/>
             <p:nvPr/>
           </p:nvSpPr>
@@ -10152,7 +10834,7 @@
       </p:grpSp>
       <p:sp>
         <p:nvSpPr>
-          <p:cNvPr id="10" name="TextBox 9"/>
+          <p:cNvPr id="11" name="TextBox 10"/>
           <p:cNvSpPr txBox="1"/>
           <p:nvPr/>
         </p:nvSpPr>
@@ -10183,6 +10865,11 @@
             </a:r>
           </a:p>
           <a:p>
+            <a:pPr>
+              <a:spcBef>
+                <a:spcPts val="1200"/>
+              </a:spcBef>
+            </a:pPr>
             <a:r>
               <a:rPr sz="2000" b="0" i="0">
                 <a:solidFill>
@@ -10221,9 +10908,41 @@
         <p:nvPr/>
       </p:nvGrpSpPr>
       <p:grpSpPr/>
+      <p:sp>
+        <p:nvSpPr>
+          <p:cNvPr id="2" name="Title 1"/>
+          <p:cNvSpPr>
+            <a:spLocks noGrp="1"/>
+          </p:cNvSpPr>
+          <p:nvPr>
+            <p:ph type="title"/>
+          </p:nvPr>
+        </p:nvSpPr>
+        <p:spPr>
+          <a:xfrm>
+            <a:off x="-12191695" y="0"/>
+            <a:ext cx="12191695" cy="914400"/>
+          </a:xfrm>
+        </p:spPr>
+        <p:txBody>
+          <a:bodyPr/>
+          <a:lstStyle/>
+          <a:p>
+            <a:r>
+              <a:t>Discussion question</a:t>
+            </a:r>
+          </a:p>
+        </p:txBody>
+      </p:sp>
       <p:grpSp>
         <p:nvGrpSpPr>
-          <p:cNvPr id="2" name="Group 1"/>
+          <p:cNvPr id="3" name="Window discuss.txt">
+            <a:extLst>
+              <a:ext uri="{C183D7F6-B498-43B3-948B-1728B52AA6E4}">
+                <adec:decorative xmlns:adec="http://schemas.microsoft.com/office/drawing/2017/decorative" val="1"/>
+              </a:ext>
+            </a:extLst>
+          </p:cNvPr>
           <p:cNvGrpSpPr/>
           <p:nvPr/>
         </p:nvGrpSpPr>
@@ -10237,7 +10956,7 @@
         </p:grpSpPr>
         <p:sp>
           <p:nvSpPr>
-            <p:cNvPr id="3" name="Rectangle 2"/>
+            <p:cNvPr id="4" name="Rectangle 3"/>
             <p:cNvSpPr/>
             <p:nvPr/>
           </p:nvSpPr>
@@ -10281,7 +11000,7 @@
         </p:sp>
         <p:sp>
           <p:nvSpPr>
-            <p:cNvPr id="4" name="Rectangle 3"/>
+            <p:cNvPr id="5" name="Rectangle 4"/>
             <p:cNvSpPr/>
             <p:nvPr/>
           </p:nvSpPr>
@@ -10327,7 +11046,7 @@
         </p:sp>
         <p:sp>
           <p:nvSpPr>
-            <p:cNvPr id="5" name="Rectangle 4"/>
+            <p:cNvPr id="6" name="Rectangle 5"/>
             <p:cNvSpPr/>
             <p:nvPr/>
           </p:nvSpPr>
@@ -10373,7 +11092,7 @@
         </p:sp>
         <p:sp>
           <p:nvSpPr>
-            <p:cNvPr id="6" name="Rectangle 5"/>
+            <p:cNvPr id="7" name="Rectangle 6"/>
             <p:cNvSpPr/>
             <p:nvPr/>
           </p:nvSpPr>
@@ -10419,7 +11138,7 @@
         </p:sp>
         <p:sp>
           <p:nvSpPr>
-            <p:cNvPr id="7" name="Rectangle 6"/>
+            <p:cNvPr id="8" name="Rectangle 7"/>
             <p:cNvSpPr/>
             <p:nvPr/>
           </p:nvSpPr>
@@ -10465,7 +11184,7 @@
         </p:sp>
         <p:sp>
           <p:nvSpPr>
-            <p:cNvPr id="8" name="Rectangle 7"/>
+            <p:cNvPr id="9" name="Rectangle 8"/>
             <p:cNvSpPr/>
             <p:nvPr/>
           </p:nvSpPr>
@@ -10511,7 +11230,7 @@
         </p:sp>
         <p:sp>
           <p:nvSpPr>
-            <p:cNvPr id="9" name="TextBox 8"/>
+            <p:cNvPr id="10" name="TextBox 9"/>
             <p:cNvSpPr txBox="1"/>
             <p:nvPr/>
           </p:nvSpPr>
@@ -10546,7 +11265,7 @@
       </p:grpSp>
       <p:sp>
         <p:nvSpPr>
-          <p:cNvPr id="10" name="TextBox 9"/>
+          <p:cNvPr id="11" name="TextBox 10"/>
           <p:cNvSpPr txBox="1"/>
           <p:nvPr/>
         </p:nvSpPr>
@@ -10577,6 +11296,11 @@
             </a:r>
           </a:p>
           <a:p>
+            <a:pPr>
+              <a:spcBef>
+                <a:spcPts val="1200"/>
+              </a:spcBef>
+            </a:pPr>
             <a:r>
               <a:rPr sz="2000" b="0" i="0">
                 <a:solidFill>
@@ -10617,14 +11341,40 @@
       <p:grpSpPr/>
       <p:sp>
         <p:nvSpPr>
-          <p:cNvPr id="2" name="TextBox 1"/>
+          <p:cNvPr id="2" name="Title 1"/>
+          <p:cNvSpPr>
+            <a:spLocks noGrp="1"/>
+          </p:cNvSpPr>
+          <p:nvPr>
+            <p:ph type="title"/>
+          </p:nvPr>
+        </p:nvSpPr>
+        <p:spPr>
+          <a:xfrm>
+            <a:off x="-12191695" y="0"/>
+            <a:ext cx="12191695" cy="914400"/>
+          </a:xfrm>
+        </p:spPr>
+        <p:txBody>
+          <a:bodyPr/>
+          <a:lstStyle/>
+          <a:p>
+            <a:r>
+              <a:t>What is digital humanities?</a:t>
+            </a:r>
+          </a:p>
+        </p:txBody>
+      </p:sp>
+      <p:sp>
+        <p:nvSpPr>
+          <p:cNvPr id="3" name="TextBox 2"/>
           <p:cNvSpPr txBox="1"/>
           <p:nvPr/>
         </p:nvSpPr>
         <p:spPr>
           <a:xfrm>
-            <a:off x="731520" y="1463040"/>
-            <a:ext cx="10728655" cy="2926080"/>
+            <a:off x="274320" y="1417320"/>
+            <a:ext cx="11643055" cy="4023360"/>
           </a:xfrm>
           <a:prstGeom prst="rect">
             <a:avLst/>
@@ -10649,9 +11399,13 @@
             </a:r>
           </a:p>
           <a:p>
-            <a:pPr algn="ctr"/>
-            <a:r>
-              <a:rPr sz="2800" b="0" i="0">
+            <a:pPr algn="ctr">
+              <a:spcBef>
+                <a:spcPts val="1000"/>
+              </a:spcBef>
+            </a:pPr>
+            <a:r>
+              <a:rPr sz="2200" b="0" i="0">
                 <a:solidFill>
                   <a:srgbClr val="FFFFFF"/>
                 </a:solidFill>
@@ -10688,9 +11442,41 @@
         <p:nvPr/>
       </p:nvGrpSpPr>
       <p:grpSpPr/>
+      <p:sp>
+        <p:nvSpPr>
+          <p:cNvPr id="2" name="Title 1"/>
+          <p:cNvSpPr>
+            <a:spLocks noGrp="1"/>
+          </p:cNvSpPr>
+          <p:nvPr>
+            <p:ph type="title"/>
+          </p:nvPr>
+        </p:nvSpPr>
+        <p:spPr>
+          <a:xfrm>
+            <a:off x="-12191695" y="0"/>
+            <a:ext cx="12191695" cy="914400"/>
+          </a:xfrm>
+        </p:spPr>
+        <p:txBody>
+          <a:bodyPr/>
+          <a:lstStyle/>
+          <a:p>
+            <a:r>
+              <a:t>Quote: Matthew Kirschenbaum, 2010, p. 56</a:t>
+            </a:r>
+          </a:p>
+        </p:txBody>
+      </p:sp>
       <p:grpSp>
         <p:nvGrpSpPr>
-          <p:cNvPr id="2" name="Group 1"/>
+          <p:cNvPr id="3" name="Window quote.txt">
+            <a:extLst>
+              <a:ext uri="{C183D7F6-B498-43B3-948B-1728B52AA6E4}">
+                <adec:decorative xmlns:adec="http://schemas.microsoft.com/office/drawing/2017/decorative" val="1"/>
+              </a:ext>
+            </a:extLst>
+          </p:cNvPr>
           <p:cNvGrpSpPr/>
           <p:nvPr/>
         </p:nvGrpSpPr>
@@ -10704,7 +11490,7 @@
         </p:grpSpPr>
         <p:sp>
           <p:nvSpPr>
-            <p:cNvPr id="3" name="Rectangle 2"/>
+            <p:cNvPr id="4" name="Rectangle 3"/>
             <p:cNvSpPr/>
             <p:nvPr/>
           </p:nvSpPr>
@@ -10748,7 +11534,7 @@
         </p:sp>
         <p:sp>
           <p:nvSpPr>
-            <p:cNvPr id="4" name="Rectangle 3"/>
+            <p:cNvPr id="5" name="Rectangle 4"/>
             <p:cNvSpPr/>
             <p:nvPr/>
           </p:nvSpPr>
@@ -10794,7 +11580,7 @@
         </p:sp>
         <p:sp>
           <p:nvSpPr>
-            <p:cNvPr id="5" name="Rectangle 4"/>
+            <p:cNvPr id="6" name="Rectangle 5"/>
             <p:cNvSpPr/>
             <p:nvPr/>
           </p:nvSpPr>
@@ -10840,7 +11626,7 @@
         </p:sp>
         <p:sp>
           <p:nvSpPr>
-            <p:cNvPr id="6" name="Rectangle 5"/>
+            <p:cNvPr id="7" name="Rectangle 6"/>
             <p:cNvSpPr/>
             <p:nvPr/>
           </p:nvSpPr>
@@ -10886,7 +11672,7 @@
         </p:sp>
         <p:sp>
           <p:nvSpPr>
-            <p:cNvPr id="7" name="Rectangle 6"/>
+            <p:cNvPr id="8" name="Rectangle 7"/>
             <p:cNvSpPr/>
             <p:nvPr/>
           </p:nvSpPr>
@@ -10932,7 +11718,7 @@
         </p:sp>
         <p:sp>
           <p:nvSpPr>
-            <p:cNvPr id="8" name="Rectangle 7"/>
+            <p:cNvPr id="9" name="Rectangle 8"/>
             <p:cNvSpPr/>
             <p:nvPr/>
           </p:nvSpPr>
@@ -10978,7 +11764,7 @@
         </p:sp>
         <p:sp>
           <p:nvSpPr>
-            <p:cNvPr id="9" name="TextBox 8"/>
+            <p:cNvPr id="10" name="TextBox 9"/>
             <p:cNvSpPr txBox="1"/>
             <p:nvPr/>
           </p:nvSpPr>
@@ -11013,7 +11799,7 @@
       </p:grpSp>
       <p:sp>
         <p:nvSpPr>
-          <p:cNvPr id="10" name="TextBox 9"/>
+          <p:cNvPr id="11" name="TextBox 10"/>
           <p:cNvSpPr txBox="1"/>
           <p:nvPr/>
         </p:nvSpPr>
@@ -11047,7 +11833,7 @@
       </p:sp>
       <p:sp>
         <p:nvSpPr>
-          <p:cNvPr id="11" name="TextBox 10"/>
+          <p:cNvPr id="12" name="TextBox 11"/>
           <p:cNvSpPr txBox="1"/>
           <p:nvPr/>
         </p:nvSpPr>
@@ -11116,9 +11902,41 @@
         <p:nvPr/>
       </p:nvGrpSpPr>
       <p:grpSpPr/>
+      <p:sp>
+        <p:nvSpPr>
+          <p:cNvPr id="2" name="Title 1"/>
+          <p:cNvSpPr>
+            <a:spLocks noGrp="1"/>
+          </p:cNvSpPr>
+          <p:nvPr>
+            <p:ph type="title"/>
+          </p:nvPr>
+        </p:nvSpPr>
+        <p:spPr>
+          <a:xfrm>
+            <a:off x="-12191695" y="0"/>
+            <a:ext cx="12191695" cy="914400"/>
+          </a:xfrm>
+        </p:spPr>
+        <p:txBody>
+          <a:bodyPr/>
+          <a:lstStyle/>
+          <a:p>
+            <a:r>
+              <a:t>Quote: Matthew Kirschenbaum, 2010, p. 56</a:t>
+            </a:r>
+          </a:p>
+        </p:txBody>
+      </p:sp>
       <p:grpSp>
         <p:nvGrpSpPr>
-          <p:cNvPr id="2" name="Group 1"/>
+          <p:cNvPr id="3" name="Window quote.txt">
+            <a:extLst>
+              <a:ext uri="{C183D7F6-B498-43B3-948B-1728B52AA6E4}">
+                <adec:decorative xmlns:adec="http://schemas.microsoft.com/office/drawing/2017/decorative" val="1"/>
+              </a:ext>
+            </a:extLst>
+          </p:cNvPr>
           <p:cNvGrpSpPr/>
           <p:nvPr/>
         </p:nvGrpSpPr>
@@ -11132,7 +11950,7 @@
         </p:grpSpPr>
         <p:sp>
           <p:nvSpPr>
-            <p:cNvPr id="3" name="Rectangle 2"/>
+            <p:cNvPr id="4" name="Rectangle 3"/>
             <p:cNvSpPr/>
             <p:nvPr/>
           </p:nvSpPr>
@@ -11176,7 +11994,7 @@
         </p:sp>
         <p:sp>
           <p:nvSpPr>
-            <p:cNvPr id="4" name="Rectangle 3"/>
+            <p:cNvPr id="5" name="Rectangle 4"/>
             <p:cNvSpPr/>
             <p:nvPr/>
           </p:nvSpPr>
@@ -11222,7 +12040,7 @@
         </p:sp>
         <p:sp>
           <p:nvSpPr>
-            <p:cNvPr id="5" name="Rectangle 4"/>
+            <p:cNvPr id="6" name="Rectangle 5"/>
             <p:cNvSpPr/>
             <p:nvPr/>
           </p:nvSpPr>
@@ -11268,7 +12086,7 @@
         </p:sp>
         <p:sp>
           <p:nvSpPr>
-            <p:cNvPr id="6" name="Rectangle 5"/>
+            <p:cNvPr id="7" name="Rectangle 6"/>
             <p:cNvSpPr/>
             <p:nvPr/>
           </p:nvSpPr>
@@ -11314,7 +12132,7 @@
         </p:sp>
         <p:sp>
           <p:nvSpPr>
-            <p:cNvPr id="7" name="Rectangle 6"/>
+            <p:cNvPr id="8" name="Rectangle 7"/>
             <p:cNvSpPr/>
             <p:nvPr/>
           </p:nvSpPr>
@@ -11360,7 +12178,7 @@
         </p:sp>
         <p:sp>
           <p:nvSpPr>
-            <p:cNvPr id="8" name="Rectangle 7"/>
+            <p:cNvPr id="9" name="Rectangle 8"/>
             <p:cNvSpPr/>
             <p:nvPr/>
           </p:nvSpPr>
@@ -11406,7 +12224,7 @@
         </p:sp>
         <p:sp>
           <p:nvSpPr>
-            <p:cNvPr id="9" name="TextBox 8"/>
+            <p:cNvPr id="10" name="TextBox 9"/>
             <p:cNvSpPr txBox="1"/>
             <p:nvPr/>
           </p:nvSpPr>
@@ -11441,7 +12259,7 @@
       </p:grpSp>
       <p:sp>
         <p:nvSpPr>
-          <p:cNvPr id="10" name="TextBox 9"/>
+          <p:cNvPr id="11" name="TextBox 10"/>
           <p:cNvSpPr txBox="1"/>
           <p:nvPr/>
         </p:nvSpPr>
@@ -11475,7 +12293,7 @@
       </p:sp>
       <p:sp>
         <p:nvSpPr>
-          <p:cNvPr id="11" name="TextBox 10"/>
+          <p:cNvPr id="12" name="TextBox 11"/>
           <p:cNvSpPr txBox="1"/>
           <p:nvPr/>
         </p:nvSpPr>
@@ -11544,9 +12362,41 @@
         <p:nvPr/>
       </p:nvGrpSpPr>
       <p:grpSpPr/>
+      <p:sp>
+        <p:nvSpPr>
+          <p:cNvPr id="2" name="Title 1"/>
+          <p:cNvSpPr>
+            <a:spLocks noGrp="1"/>
+          </p:cNvSpPr>
+          <p:nvPr>
+            <p:ph type="title"/>
+          </p:nvPr>
+        </p:nvSpPr>
+        <p:spPr>
+          <a:xfrm>
+            <a:off x="-12191695" y="0"/>
+            <a:ext cx="12191695" cy="914400"/>
+          </a:xfrm>
+        </p:spPr>
+        <p:txBody>
+          <a:bodyPr/>
+          <a:lstStyle/>
+          <a:p>
+            <a:r>
+              <a:t>Quote: Brett Bobley (NEH), quoted in Kirschenbaum, 2010, p. 57</a:t>
+            </a:r>
+          </a:p>
+        </p:txBody>
+      </p:sp>
       <p:grpSp>
         <p:nvGrpSpPr>
-          <p:cNvPr id="2" name="Group 1"/>
+          <p:cNvPr id="3" name="Window quote.txt">
+            <a:extLst>
+              <a:ext uri="{C183D7F6-B498-43B3-948B-1728B52AA6E4}">
+                <adec:decorative xmlns:adec="http://schemas.microsoft.com/office/drawing/2017/decorative" val="1"/>
+              </a:ext>
+            </a:extLst>
+          </p:cNvPr>
           <p:cNvGrpSpPr/>
           <p:nvPr/>
         </p:nvGrpSpPr>
@@ -11560,7 +12410,7 @@
         </p:grpSpPr>
         <p:sp>
           <p:nvSpPr>
-            <p:cNvPr id="3" name="Rectangle 2"/>
+            <p:cNvPr id="4" name="Rectangle 3"/>
             <p:cNvSpPr/>
             <p:nvPr/>
           </p:nvSpPr>
@@ -11604,7 +12454,7 @@
         </p:sp>
         <p:sp>
           <p:nvSpPr>
-            <p:cNvPr id="4" name="Rectangle 3"/>
+            <p:cNvPr id="5" name="Rectangle 4"/>
             <p:cNvSpPr/>
             <p:nvPr/>
           </p:nvSpPr>
@@ -11650,7 +12500,7 @@
         </p:sp>
         <p:sp>
           <p:nvSpPr>
-            <p:cNvPr id="5" name="Rectangle 4"/>
+            <p:cNvPr id="6" name="Rectangle 5"/>
             <p:cNvSpPr/>
             <p:nvPr/>
           </p:nvSpPr>
@@ -11696,7 +12546,7 @@
         </p:sp>
         <p:sp>
           <p:nvSpPr>
-            <p:cNvPr id="6" name="Rectangle 5"/>
+            <p:cNvPr id="7" name="Rectangle 6"/>
             <p:cNvSpPr/>
             <p:nvPr/>
           </p:nvSpPr>
@@ -11742,7 +12592,7 @@
         </p:sp>
         <p:sp>
           <p:nvSpPr>
-            <p:cNvPr id="7" name="Rectangle 6"/>
+            <p:cNvPr id="8" name="Rectangle 7"/>
             <p:cNvSpPr/>
             <p:nvPr/>
           </p:nvSpPr>
@@ -11788,7 +12638,7 @@
         </p:sp>
         <p:sp>
           <p:nvSpPr>
-            <p:cNvPr id="8" name="Rectangle 7"/>
+            <p:cNvPr id="9" name="Rectangle 8"/>
             <p:cNvSpPr/>
             <p:nvPr/>
           </p:nvSpPr>
@@ -11834,7 +12684,7 @@
         </p:sp>
         <p:sp>
           <p:nvSpPr>
-            <p:cNvPr id="9" name="TextBox 8"/>
+            <p:cNvPr id="10" name="TextBox 9"/>
             <p:cNvSpPr txBox="1"/>
             <p:nvPr/>
           </p:nvSpPr>
@@ -11869,7 +12719,7 @@
       </p:grpSp>
       <p:sp>
         <p:nvSpPr>
-          <p:cNvPr id="10" name="TextBox 9"/>
+          <p:cNvPr id="11" name="TextBox 10"/>
           <p:cNvSpPr txBox="1"/>
           <p:nvPr/>
         </p:nvSpPr>
@@ -11903,7 +12753,7 @@
       </p:sp>
       <p:sp>
         <p:nvSpPr>
-          <p:cNvPr id="11" name="TextBox 10"/>
+          <p:cNvPr id="12" name="TextBox 11"/>
           <p:cNvSpPr txBox="1"/>
           <p:nvPr/>
         </p:nvSpPr>
@@ -11972,9 +12822,41 @@
         <p:nvPr/>
       </p:nvGrpSpPr>
       <p:grpSpPr/>
+      <p:sp>
+        <p:nvSpPr>
+          <p:cNvPr id="2" name="Title 1"/>
+          <p:cNvSpPr>
+            <a:spLocks noGrp="1"/>
+          </p:cNvSpPr>
+          <p:nvPr>
+            <p:ph type="title"/>
+          </p:nvPr>
+        </p:nvSpPr>
+        <p:spPr>
+          <a:xfrm>
+            <a:off x="-12191695" y="0"/>
+            <a:ext cx="12191695" cy="914400"/>
+          </a:xfrm>
+        </p:spPr>
+        <p:txBody>
+          <a:bodyPr/>
+          <a:lstStyle/>
+          <a:p>
+            <a:r>
+              <a:t>Quote: Matthew Kirschenbaum, 2010, p. 60</a:t>
+            </a:r>
+          </a:p>
+        </p:txBody>
+      </p:sp>
       <p:grpSp>
         <p:nvGrpSpPr>
-          <p:cNvPr id="2" name="Group 1"/>
+          <p:cNvPr id="3" name="Window quote.txt">
+            <a:extLst>
+              <a:ext uri="{C183D7F6-B498-43B3-948B-1728B52AA6E4}">
+                <adec:decorative xmlns:adec="http://schemas.microsoft.com/office/drawing/2017/decorative" val="1"/>
+              </a:ext>
+            </a:extLst>
+          </p:cNvPr>
           <p:cNvGrpSpPr/>
           <p:nvPr/>
         </p:nvGrpSpPr>
@@ -11988,7 +12870,7 @@
         </p:grpSpPr>
         <p:sp>
           <p:nvSpPr>
-            <p:cNvPr id="3" name="Rectangle 2"/>
+            <p:cNvPr id="4" name="Rectangle 3"/>
             <p:cNvSpPr/>
             <p:nvPr/>
           </p:nvSpPr>
@@ -12032,7 +12914,7 @@
         </p:sp>
         <p:sp>
           <p:nvSpPr>
-            <p:cNvPr id="4" name="Rectangle 3"/>
+            <p:cNvPr id="5" name="Rectangle 4"/>
             <p:cNvSpPr/>
             <p:nvPr/>
           </p:nvSpPr>
@@ -12078,7 +12960,7 @@
         </p:sp>
         <p:sp>
           <p:nvSpPr>
-            <p:cNvPr id="5" name="Rectangle 4"/>
+            <p:cNvPr id="6" name="Rectangle 5"/>
             <p:cNvSpPr/>
             <p:nvPr/>
           </p:nvSpPr>
@@ -12124,7 +13006,7 @@
         </p:sp>
         <p:sp>
           <p:nvSpPr>
-            <p:cNvPr id="6" name="Rectangle 5"/>
+            <p:cNvPr id="7" name="Rectangle 6"/>
             <p:cNvSpPr/>
             <p:nvPr/>
           </p:nvSpPr>
@@ -12170,7 +13052,7 @@
         </p:sp>
         <p:sp>
           <p:nvSpPr>
-            <p:cNvPr id="7" name="Rectangle 6"/>
+            <p:cNvPr id="8" name="Rectangle 7"/>
             <p:cNvSpPr/>
             <p:nvPr/>
           </p:nvSpPr>
@@ -12216,7 +13098,7 @@
         </p:sp>
         <p:sp>
           <p:nvSpPr>
-            <p:cNvPr id="8" name="Rectangle 7"/>
+            <p:cNvPr id="9" name="Rectangle 8"/>
             <p:cNvSpPr/>
             <p:nvPr/>
           </p:nvSpPr>
@@ -12262,7 +13144,7 @@
         </p:sp>
         <p:sp>
           <p:nvSpPr>
-            <p:cNvPr id="9" name="TextBox 8"/>
+            <p:cNvPr id="10" name="TextBox 9"/>
             <p:cNvSpPr txBox="1"/>
             <p:nvPr/>
           </p:nvSpPr>
@@ -12297,7 +13179,7 @@
       </p:grpSp>
       <p:sp>
         <p:nvSpPr>
-          <p:cNvPr id="10" name="TextBox 9"/>
+          <p:cNvPr id="11" name="TextBox 10"/>
           <p:cNvSpPr txBox="1"/>
           <p:nvPr/>
         </p:nvSpPr>
@@ -12331,7 +13213,7 @@
       </p:sp>
       <p:sp>
         <p:nvSpPr>
-          <p:cNvPr id="11" name="TextBox 10"/>
+          <p:cNvPr id="12" name="TextBox 11"/>
           <p:cNvSpPr txBox="1"/>
           <p:nvPr/>
         </p:nvSpPr>
@@ -12402,14 +13284,40 @@
       <p:grpSpPr/>
       <p:sp>
         <p:nvSpPr>
-          <p:cNvPr id="2" name="TextBox 1"/>
+          <p:cNvPr id="2" name="Title 1"/>
+          <p:cNvSpPr>
+            <a:spLocks noGrp="1"/>
+          </p:cNvSpPr>
+          <p:nvPr>
+            <p:ph type="title"/>
+          </p:nvPr>
+        </p:nvSpPr>
+        <p:spPr>
+          <a:xfrm>
+            <a:off x="-12191695" y="0"/>
+            <a:ext cx="12191695" cy="914400"/>
+          </a:xfrm>
+        </p:spPr>
+        <p:txBody>
+          <a:bodyPr/>
+          <a:lstStyle/>
+          <a:p>
+            <a:r>
+              <a:t>Talking to machines</a:t>
+            </a:r>
+          </a:p>
+        </p:txBody>
+      </p:sp>
+      <p:sp>
+        <p:nvSpPr>
+          <p:cNvPr id="3" name="TextBox 2"/>
           <p:cNvSpPr txBox="1"/>
           <p:nvPr/>
         </p:nvSpPr>
         <p:spPr>
           <a:xfrm>
-            <a:off x="731520" y="1463040"/>
-            <a:ext cx="10728655" cy="2926080"/>
+            <a:off x="274320" y="1417320"/>
+            <a:ext cx="11643055" cy="4023360"/>
           </a:xfrm>
           <a:prstGeom prst="rect">
             <a:avLst/>
@@ -12434,7 +13342,11 @@
             </a:r>
           </a:p>
           <a:p>
-            <a:pPr algn="ctr"/>
+            <a:pPr algn="ctr">
+              <a:spcBef>
+                <a:spcPts val="1000"/>
+              </a:spcBef>
+            </a:pPr>
             <a:r>
               <a:rPr sz="2800" b="0" i="0">
                 <a:solidFill>
@@ -12473,9 +13385,41 @@
         <p:nvPr/>
       </p:nvGrpSpPr>
       <p:grpSpPr/>
+      <p:sp>
+        <p:nvSpPr>
+          <p:cNvPr id="2" name="Title 1"/>
+          <p:cNvSpPr>
+            <a:spLocks noGrp="1"/>
+          </p:cNvSpPr>
+          <p:nvPr>
+            <p:ph type="title"/>
+          </p:nvPr>
+        </p:nvSpPr>
+        <p:spPr>
+          <a:xfrm>
+            <a:off x="-12191695" y="0"/>
+            <a:ext cx="12191695" cy="914400"/>
+          </a:xfrm>
+        </p:spPr>
+        <p:txBody>
+          <a:bodyPr/>
+          <a:lstStyle/>
+          <a:p>
+            <a:r>
+              <a:t>Turing's imitation game (1950): can a judge tell the machine from the person by text alone?</a:t>
+            </a:r>
+          </a:p>
+        </p:txBody>
+      </p:sp>
       <p:grpSp>
         <p:nvGrpSpPr>
-          <p:cNvPr id="2" name="Group 1"/>
+          <p:cNvPr id="3" name="Window image.png">
+            <a:extLst>
+              <a:ext uri="{C183D7F6-B498-43B3-948B-1728B52AA6E4}">
+                <adec:decorative xmlns:adec="http://schemas.microsoft.com/office/drawing/2017/decorative" val="1"/>
+              </a:ext>
+            </a:extLst>
+          </p:cNvPr>
           <p:cNvGrpSpPr/>
           <p:nvPr/>
         </p:nvGrpSpPr>
@@ -12489,7 +13433,7 @@
         </p:grpSpPr>
         <p:sp>
           <p:nvSpPr>
-            <p:cNvPr id="3" name="Rectangle 2"/>
+            <p:cNvPr id="4" name="Rectangle 3"/>
             <p:cNvSpPr/>
             <p:nvPr/>
           </p:nvSpPr>
@@ -12533,7 +13477,7 @@
         </p:sp>
         <p:sp>
           <p:nvSpPr>
-            <p:cNvPr id="4" name="Rectangle 3"/>
+            <p:cNvPr id="5" name="Rectangle 4"/>
             <p:cNvSpPr/>
             <p:nvPr/>
           </p:nvSpPr>
@@ -12579,7 +13523,7 @@
         </p:sp>
         <p:sp>
           <p:nvSpPr>
-            <p:cNvPr id="5" name="Rectangle 4"/>
+            <p:cNvPr id="6" name="Rectangle 5"/>
             <p:cNvSpPr/>
             <p:nvPr/>
           </p:nvSpPr>
@@ -12625,7 +13569,7 @@
         </p:sp>
         <p:sp>
           <p:nvSpPr>
-            <p:cNvPr id="6" name="Rectangle 5"/>
+            <p:cNvPr id="7" name="Rectangle 6"/>
             <p:cNvSpPr/>
             <p:nvPr/>
           </p:nvSpPr>
@@ -12671,7 +13615,7 @@
         </p:sp>
         <p:sp>
           <p:nvSpPr>
-            <p:cNvPr id="7" name="Rectangle 6"/>
+            <p:cNvPr id="8" name="Rectangle 7"/>
             <p:cNvSpPr/>
             <p:nvPr/>
           </p:nvSpPr>
@@ -12717,7 +13661,7 @@
         </p:sp>
         <p:sp>
           <p:nvSpPr>
-            <p:cNvPr id="8" name="Rectangle 7"/>
+            <p:cNvPr id="9" name="Rectangle 8"/>
             <p:cNvSpPr/>
             <p:nvPr/>
           </p:nvSpPr>
@@ -12763,7 +13707,7 @@
         </p:sp>
         <p:sp>
           <p:nvSpPr>
-            <p:cNvPr id="9" name="TextBox 8"/>
+            <p:cNvPr id="10" name="TextBox 9"/>
             <p:cNvSpPr txBox="1"/>
             <p:nvPr/>
           </p:nvSpPr>
@@ -12798,7 +13742,7 @@
       </p:grpSp>
       <p:pic>
         <p:nvPicPr>
-          <p:cNvPr id="10" name="Picture 9" descr="Diagram of the imitation game: a computer labeled A and a person labeled B sit behind a wall, each passing a paper slip to a person labeled C who must judge which is which."/>
+          <p:cNvPr id="11" name="Picture 10" descr="Diagram of the imitation game: a computer labeled A and a person labeled B sit behind a wall, each passing a paper slip to a person labeled C who must judge which is which."/>
           <p:cNvPicPr>
             <a:picLocks noChangeAspect="1"/>
           </p:cNvPicPr>
@@ -12822,13 +13766,13 @@
       </p:pic>
       <p:sp>
         <p:nvSpPr>
-          <p:cNvPr id="11" name="TextBox 10"/>
+          <p:cNvPr id="12" name="TextBox 11"/>
           <p:cNvSpPr txBox="1"/>
           <p:nvPr/>
         </p:nvSpPr>
         <p:spPr>
           <a:xfrm>
-            <a:off x="822960" y="5989320"/>
+            <a:off x="822960" y="5943600"/>
             <a:ext cx="10545775" cy="731520"/>
           </a:xfrm>
           <a:prstGeom prst="rect">
@@ -12844,7 +13788,7 @@
           <a:p>
             <a:pPr algn="ctr"/>
             <a:r>
-              <a:rPr sz="1800" b="0" i="0">
+              <a:rPr sz="1600" b="0" i="0">
                 <a:solidFill>
                   <a:srgbClr val="1B1035"/>
                 </a:solidFill>

</xml_diff>